<commit_message>
slides: 공용 덱에 Antigravity CLI 설치와 Git 복구 절 추가
- Antigravity를 편집기와 CLI(agy) 두 형태로 나누어 설치 슬라이드를 분리
- 권한 모드 표와 명령 표에 Antigravity CLI 열 추가
- "첫 지시 문장"과 "결과 확인 항목"을 빼고 Git 커밋·복구 절로 대체
- 그림 tools_landscape.png 다시 생성

Co-Authored-By: Claude Fable 5.1 <noreply@anthropic.com>
Claude-Session: https://claude.ai/code/session_01Kmea1hRdqoMcnWuLxJ1h6x
</commit_message>
<xml_diff>
--- a/slides/common/dev_env.pptx
+++ b/slides/common/dev_env.pptx
@@ -675,7 +675,7 @@
           <a:lstStyle/>
           <a:p>
             <a:r>
-              <a:t>Antigravity는 편집기 안에서 에이전트를 사용하는 형태입니다. 터미널 사용이 익숙하지 않은 학생은 이 도구로 시작할 수 있습니다. macOS용 설치 파일은 Apple Silicon과 Intel을 구분해 제공하므로 자신의 기기에 맞는 파일을 선택합니다.</a:t>
+              <a:t>Antigravity는 편집기와 터미널 CLI 두 가지 형태로 제공되고, 둘 중 하나만 설치해도 됩니다. 편집기는 화면 안에서 에이전트를 사용하는 형태여서 터미널이 익숙하지 않은 학생이 시작하기 쉽습니다. macOS용 설치 파일은 Apple Silicon과 Intel을 구분해 제공하므로 자신의 기기에 맞는 파일을 선택합니다.</a:t>
             </a:r>
           </a:p>
         </p:txBody>
@@ -745,7 +745,7 @@
           <a:lstStyle/>
           <a:p>
             <a:r>
-              <a:t>여러 도구를 설치해 두면 한 도구의 사용 한도를 모두 썼거나 서비스에 접속할 수 없을 때 다른 도구로 작업을 이어갈 수 있습니다. 과제에서는 사용한 도구의 종류를 평가하지 않습니다. 학생 계정 지원 여부는 단톡방에서 별도로 안내합니다.</a:t>
+              <a:t>명령 이름은 agy입니다. macOS와 Linux는 홈 폴더 아래 .local/bin에 설치되므로 agy 명령을 찾지 못하면 PATH에 이 경로가 있는지 확인합니다. Node.js는 필요하지 않습니다.</a:t>
             </a:r>
           </a:p>
         </p:txBody>
@@ -815,7 +815,7 @@
           <a:lstStyle/>
           <a:p>
             <a:r>
-              <a:t>에이전트를 잘못된 폴더에서 실행하면 의도하지 않은 파일을 수정할 수 있습니다. 작업을 시작할 때 현재 경로와 파일 목록을 먼저 확인합니다.</a:t>
+              <a:t>여러 도구를 설치해 두면 한 도구의 사용 한도를 모두 썼거나 서비스에 접속할 수 없을 때 다른 도구로 작업을 이어갈 수 있습니다. 과제에서는 사용한 도구의 종류를 평가하지 않습니다. 학생 계정 지원 여부는 단톡방에서 별도로 안내합니다.</a:t>
             </a:r>
           </a:p>
         </p:txBody>
@@ -885,7 +885,7 @@
           <a:lstStyle/>
           <a:p>
             <a:r>
-              <a:t>Claude Code에서 Shift+Tab을 누르면 기본, acceptEdits, plan, bypassPermissions 순서로 전환되고 현재 모드가 화면 아래에 표시됩니다. 수업에서는 plan 모드로 계획을 확인한 뒤 실행 단계로 넘어가는 순서를 권장합니다.</a:t>
+              <a:t>에이전트를 잘못된 폴더에서 실행하면 의도하지 않은 파일을 수정할 수 있습니다. 작업을 시작할 때 현재 경로와 파일 목록을 먼저 확인합니다. 여기서 각자 한 번 실행해 보고, 설치를 마친 학생은 파이썬 버전과 설치된 패키지를 점검하도록 지시해 봅니다.</a:t>
             </a:r>
           </a:p>
         </p:txBody>
@@ -955,7 +955,7 @@
           <a:lstStyle/>
           <a:p>
             <a:r>
-              <a:t>전면 자동은 확인을 생략하는 기능이 아니라 확인 시점을 뒤로 옮기는 기능입니다. 커밋하지 않은 상태에서 사용하면 잘못된 수정을 복구하기 어렵습니다. 커밋한 뒤에 실행하고, 작업이 끝나면 git diff로 변경 내용을 확인합니다.</a:t>
+              <a:t>Claude Code에서 Shift+Tab을 누르면 기본, acceptEdits, plan, bypassPermissions 순서로 전환되고 현재 모드가 화면 아래에 표시됩니다. 수업에서는 plan 모드로 계획을 확인한 뒤 실행 단계로 넘어가는 순서를 권장합니다.</a:t>
             </a:r>
           </a:p>
         </p:txBody>
@@ -1025,7 +1025,7 @@
           <a:lstStyle/>
           <a:p>
             <a:r>
-              <a:t>각자 에이전트에게 한 번 지시해 봅니다. 설치를 이미 마친 학생은 파이썬 버전과 설치된 패키지를 점검하도록 요청합니다. 지시에는 작업 목적과 실패했을 때 보고할 내용을 포함하면 충분합니다.</a:t>
+              <a:t>에이전트가 파일 수십 개를 한 번에 고쳐도, 커밋해 둔 지점이 있으면 그 상태로 되돌릴 수 있습니다. 커밋하지 않은 상태에서 덮어쓴 파일은 편집기의 실행 취소로 복구되지 않습니다. Git 사용법은 실습에서 이어서 다루고, 오늘은 에이전트를 실행하기 전에 커밋한다는 순서만 정합니다.</a:t>
             </a:r>
           </a:p>
         </p:txBody>
@@ -1095,7 +1095,7 @@
           <a:lstStyle/>
           <a:p>
             <a:r>
-              <a:t>평가에서는 어떤 도구를 사용했는지보다 결과를 설명하고 검증할 수 있는지를 확인합니다. 작성한 코드와 분석 결과를 설명하지 못하면 제출물의 타당성을 평가할 수 없습니다.</a:t>
+              <a:t>전면 자동은 확인을 생략하는 기능이 아니라 확인 시점을 뒤로 옮기는 기능입니다. 세 조건은 모두 되돌릴 수 있는 상태를 만드는 데 목적이 있습니다. 작업이 끝나면 git diff로 변경 내용을 확인하고, 의도와 다르면 git restore로 되돌립니다.</a:t>
             </a:r>
           </a:p>
         </p:txBody>
@@ -1165,7 +1165,7 @@
           <a:lstStyle/>
           <a:p>
             <a:r>
-              <a:t>코드 작성 뒤에는 원본 행 수, 결측 처리, 필터 범위를 차례로 확인합니다. 두 과목의 과제에서도 이 검증 과정을 평가합니다.</a:t>
+              <a:t>평가에서는 어떤 도구를 사용했는지보다 결과를 설명하고 검증할 수 있는지를 확인합니다. 작성한 코드와 분석 결과를 설명하지 못하면 제출물의 타당성을 평가할 수 없습니다.</a:t>
             </a:r>
           </a:p>
         </p:txBody>
@@ -1235,7 +1235,7 @@
           <a:lstStyle/>
           <a:p>
             <a:r>
-              <a:t>전체 명령 목록은 /help로 확인할 수 있습니다. 이번 시간에는 표의 네 가지를 먼저 익히고, 나머지는 필요할 때 찾아 쓰도록 안내합니다.</a:t>
+              <a:t>전체 명령 목록은 Claude Code와 Codex에서 /help, Antigravity에서 물음표 하나로 확인할 수 있습니다. 표의 미지원 두 칸은 2026년 9월 공식 문서 기준이므로 학기 중에 추가될 수 있습니다.</a:t>
             </a:r>
           </a:p>
         </p:txBody>
@@ -2285,7 +2285,7 @@
           <a:lstStyle/>
           <a:p>
             <a:r>
-              <a:t>편집기에서는 사용자가 코드를 직접 읽고 수정합니다. 터미널 에이전트는 사용자의 지시에 따라 파일을 수정하고 명령을 실행합니다. 두 도구 모두 같은 프로젝트 폴더를 대상으로 작업합니다. 그림 오른쪽의 Orca는 마지막에 용도만 소개합니다.</a:t>
+              <a:t>편집기에서는 사용자가 코드를 직접 읽고 수정합니다. 터미널 에이전트는 사용자의 지시에 따라 파일을 수정하고 명령을 실행합니다. Antigravity는 편집기와 터미널 에이전트 양쪽으로 제공되어 두 칸에 모두 들어갑니다. 그림 오른쪽의 Orca는 마지막에 용도만 소개합니다.</a:t>
             </a:r>
           </a:p>
         </p:txBody>
@@ -6261,7 +6261,7 @@
               <a:t>3.4  </a:t>
             </a:r>
             <a:r>
-              <a:t>Antigravity 설치</a:t>
+              <a:t>Antigravity 편집기 설치</a:t>
             </a:r>
           </a:p>
           <a:p>
@@ -6277,6 +6277,24 @@
                 </a:solidFill>
               </a:rPr>
               <a:t>3.5  </a:t>
+            </a:r>
+            <a:r>
+              <a:t>Antigravity CLI 설치</a:t>
+            </a:r>
+          </a:p>
+          <a:p>
+            <a:pPr>
+              <a:spcAft>
+                <a:spcPts val="1000"/>
+              </a:spcAft>
+            </a:pPr>
+            <a:r>
+              <a:rPr>
+                <a:solidFill>
+                  <a:srgbClr val="AFAFAF"/>
+                </a:solidFill>
+              </a:rPr>
+              <a:t>3.6  </a:t>
             </a:r>
             <a:r>
               <a:t>계정과 사용 한도</a:t>
@@ -6361,13 +6379,13 @@
           <a:p>
             <a:pPr/>
             <a:r>
-              <a:t>편집기: 사람이 코드를 보고 고치는 곳</a:t>
+              <a:t>편집기: 사람이 코드를 보고 고치는 곳 — VS Code, Antigravity</a:t>
             </a:r>
           </a:p>
           <a:p>
             <a:pPr/>
             <a:r>
-              <a:t>터미널 에이전트: 지시를 받아 파일을 직접 고치는 프로그램</a:t>
+              <a:t>터미널 에이전트: 지시를 받아 파일을 직접 고치는 프로그램 — claude, codex, agy</a:t>
             </a:r>
           </a:p>
           <a:p>
@@ -6819,7 +6837,7 @@
           <a:lstStyle/>
           <a:p>
             <a:r>
-              <a:t>3.4 Antigravity 설치</a:t>
+              <a:t>3.4 Antigravity 편집기 설치</a:t>
             </a:r>
           </a:p>
         </p:txBody>
@@ -6967,7 +6985,167 @@
           <a:lstStyle/>
           <a:p>
             <a:r>
-              <a:t>3.5 계정과 사용 한도</a:t>
+              <a:t>3.5 Antigravity CLI 설치</a:t>
+            </a:r>
+          </a:p>
+        </p:txBody>
+      </p:sp>
+      <p:sp>
+        <p:nvSpPr>
+          <p:cNvPr id="3" name="Text Placeholder 2"/>
+          <p:cNvSpPr>
+            <a:spLocks noGrp="1"/>
+          </p:cNvSpPr>
+          <p:nvPr>
+            <p:ph type="body" idx="101"/>
+          </p:nvPr>
+        </p:nvSpPr>
+        <p:spPr/>
+        <p:txBody>
+          <a:bodyPr/>
+          <a:lstStyle/>
+          <a:p>
+            <a:r>
+              <a:t>3. AI 코딩 도구</a:t>
+            </a:r>
+          </a:p>
+        </p:txBody>
+      </p:sp>
+      <p:sp>
+        <p:nvSpPr>
+          <p:cNvPr id="4" name="Text Placeholder 3"/>
+          <p:cNvSpPr>
+            <a:spLocks noGrp="1"/>
+          </p:cNvSpPr>
+          <p:nvPr>
+            <p:ph type="body" idx="102"/>
+          </p:nvPr>
+        </p:nvSpPr>
+        <p:spPr/>
+        <p:txBody>
+          <a:bodyPr/>
+          <a:lstStyle/>
+          <a:p>
+            <a:pPr/>
+            <a:r>
+              <a:t>설치 명령</a:t>
+            </a:r>
+          </a:p>
+          <a:p>
+            <a:pPr lvl="1"/>
+            <a:r>
+              <a:t>Windows PowerShell: irm https://antigravity.google/cli/install.ps1 | iex</a:t>
+            </a:r>
+          </a:p>
+          <a:p>
+            <a:pPr lvl="1"/>
+            <a:r>
+              <a:t>macOS·Linux: curl -fsSL https://antigravity.google/cli/install.sh | bash</a:t>
+            </a:r>
+          </a:p>
+          <a:p>
+            <a:pPr/>
+            <a:r>
+              <a:t>확인: agy --version → 버전 번호 출력</a:t>
+            </a:r>
+          </a:p>
+          <a:p>
+            <a:pPr/>
+            <a:r>
+              <a:t>첫 실행: 프로젝트 폴더에서 agy 입력 → 구글 계정으로 브라우저 로그인</a:t>
+            </a:r>
+          </a:p>
+          <a:p>
+            <a:pPr/>
+            <a:r>
+              <a:t>위치: Claude Code, Codex와 같은 터미널 에이전트</a:t>
+            </a:r>
+          </a:p>
+        </p:txBody>
+      </p:sp>
+      <p:sp>
+        <p:nvSpPr>
+          <p:cNvPr id="25" name="Slide Number Placeholder 0"/>
+          <p:cNvSpPr>
+            <a:spLocks noGrp="1"/>
+          </p:cNvSpPr>
+          <p:nvPr>
+            <p:ph type="sldNum" sz="quarter" idx="4294967295"/>
+          </p:nvPr>
+        </p:nvSpPr>
+        <p:spPr>
+          <a:xfrm>
+            <a:off x="10591495" y="6355080"/>
+            <a:ext cx="914400" cy="274320"/>
+          </a:xfrm>
+          <a:prstGeom prst="rect">
+            <a:avLst/>
+          </a:prstGeom>
+          <a:extLst>
+            <a:ext uri="{C572A759-6A51-4108-AA02-DFA0A04FC94B}">
+              <ma14:wrappingTextBoxFlag xmlns:ma14="http://schemas.microsoft.com/office/mac/drawingml/2011/main" val="0"/>
+            </a:ext>
+          </a:extLst>
+        </p:spPr>
+        <p:txBody>
+          <a:bodyPr/>
+          <a:lstStyle>
+            <a:lvl1pPr>
+              <a:defRPr sz="1000">
+                <a:solidFill>
+                  <a:srgbClr val="AFAFAF"/>
+                </a:solidFill>
+                <a:latin typeface="Pretendard Medium"/>
+                <a:ea typeface="Pretendard Medium"/>
+                <a:cs typeface="Pretendard Medium"/>
+              </a:defRPr>
+            </a:lvl1pPr>
+          </a:lstStyle>
+          <a:p>
+            <a:pPr algn="r"/>
+            <a:fld id="{F7021451-1387-4CA6-816F-3879F97B5CBC}" type="slidenum">
+              <a:rPr b="0" lang="en-US"/>
+              <a:t>1004</a:t>
+            </a:fld>
+            <a:endParaRPr lang="en-US"/>
+          </a:p>
+        </p:txBody>
+      </p:sp>
+    </p:spTree>
+  </p:cSld>
+  <p:clrMapOvr>
+    <a:masterClrMapping/>
+  </p:clrMapOvr>
+</p:sld>
+</file>
+
+<file path=ppt/slides/slide17.xml><?xml version="1.0" encoding="utf-8"?>
+<p:sld xmlns:a="http://schemas.openxmlformats.org/drawingml/2006/main" xmlns:p="http://schemas.openxmlformats.org/presentationml/2006/main" xmlns:r="http://schemas.openxmlformats.org/officeDocument/2006/relationships">
+  <p:cSld>
+    <p:spTree>
+      <p:nvGrpSpPr>
+        <p:cNvPr id="1" name=""/>
+        <p:cNvGrpSpPr/>
+        <p:nvPr/>
+      </p:nvGrpSpPr>
+      <p:grpSpPr/>
+      <p:sp>
+        <p:nvSpPr>
+          <p:cNvPr id="2" name="Title 1"/>
+          <p:cNvSpPr>
+            <a:spLocks noGrp="1"/>
+          </p:cNvSpPr>
+          <p:nvPr>
+            <p:ph type="title" idx="100"/>
+          </p:nvPr>
+        </p:nvSpPr>
+        <p:spPr/>
+        <p:txBody>
+          <a:bodyPr/>
+          <a:lstStyle/>
+          <a:p>
+            <a:r>
+              <a:t>3.6 계정과 사용 한도</a:t>
             </a:r>
           </a:p>
         </p:txBody>
@@ -7708,172 +7886,6 @@
 </p:sld>
 </file>
 
-<file path=ppt/slides/slide17.xml><?xml version="1.0" encoding="utf-8"?>
-<p:sld xmlns:a="http://schemas.openxmlformats.org/drawingml/2006/main" xmlns:p="http://schemas.openxmlformats.org/presentationml/2006/main" xmlns:r="http://schemas.openxmlformats.org/officeDocument/2006/relationships">
-  <p:cSld>
-    <p:spTree>
-      <p:nvGrpSpPr>
-        <p:cNvPr id="1" name=""/>
-        <p:cNvGrpSpPr/>
-        <p:nvPr/>
-      </p:nvGrpSpPr>
-      <p:grpSpPr/>
-      <p:sp>
-        <p:nvSpPr>
-          <p:cNvPr id="2" name="Text Placeholder 1"/>
-          <p:cNvSpPr>
-            <a:spLocks noGrp="1"/>
-          </p:cNvSpPr>
-          <p:nvPr>
-            <p:ph type="body" idx="100"/>
-          </p:nvPr>
-        </p:nvSpPr>
-        <p:spPr/>
-        <p:txBody>
-          <a:bodyPr/>
-          <a:lstStyle/>
-          <a:p>
-            <a:r>
-              <a:t>04</a:t>
-            </a:r>
-          </a:p>
-        </p:txBody>
-      </p:sp>
-      <p:sp>
-        <p:nvSpPr>
-          <p:cNvPr id="3" name="Title 2"/>
-          <p:cNvSpPr>
-            <a:spLocks noGrp="1"/>
-          </p:cNvSpPr>
-          <p:nvPr>
-            <p:ph type="title" idx="101"/>
-          </p:nvPr>
-        </p:nvSpPr>
-        <p:spPr/>
-        <p:txBody>
-          <a:bodyPr/>
-          <a:lstStyle/>
-          <a:p>
-            <a:r>
-              <a:t>에이전트 실행과 권한</a:t>
-            </a:r>
-          </a:p>
-        </p:txBody>
-      </p:sp>
-      <p:sp>
-        <p:nvSpPr>
-          <p:cNvPr id="4" name="Text Placeholder 3"/>
-          <p:cNvSpPr>
-            <a:spLocks noGrp="1"/>
-          </p:cNvSpPr>
-          <p:nvPr>
-            <p:ph type="body" idx="102"/>
-          </p:nvPr>
-        </p:nvSpPr>
-        <p:spPr/>
-        <p:txBody>
-          <a:bodyPr/>
-          <a:lstStyle/>
-          <a:p>
-            <a:pPr>
-              <a:spcAft>
-                <a:spcPts val="1000"/>
-              </a:spcAft>
-            </a:pPr>
-            <a:r>
-              <a:rPr>
-                <a:solidFill>
-                  <a:srgbClr val="AFAFAF"/>
-                </a:solidFill>
-              </a:rPr>
-              <a:t>4.1  </a:t>
-            </a:r>
-            <a:r>
-              <a:t>에이전트를 여는 위치</a:t>
-            </a:r>
-          </a:p>
-          <a:p>
-            <a:pPr>
-              <a:spcAft>
-                <a:spcPts val="1000"/>
-              </a:spcAft>
-            </a:pPr>
-            <a:r>
-              <a:rPr>
-                <a:solidFill>
-                  <a:srgbClr val="AFAFAF"/>
-                </a:solidFill>
-              </a:rPr>
-              <a:t>4.2  </a:t>
-            </a:r>
-            <a:r>
-              <a:t>권한 모드 세 단계</a:t>
-            </a:r>
-          </a:p>
-          <a:p>
-            <a:pPr>
-              <a:spcAft>
-                <a:spcPts val="1000"/>
-              </a:spcAft>
-            </a:pPr>
-            <a:r>
-              <a:rPr>
-                <a:solidFill>
-                  <a:srgbClr val="AFAFAF"/>
-                </a:solidFill>
-              </a:rPr>
-              <a:t>4.3  </a:t>
-            </a:r>
-            <a:r>
-              <a:t>전면 자동을 쓰는 조건</a:t>
-            </a:r>
-          </a:p>
-          <a:p>
-            <a:pPr>
-              <a:spcAft>
-                <a:spcPts val="1000"/>
-              </a:spcAft>
-            </a:pPr>
-            <a:r>
-              <a:rPr>
-                <a:solidFill>
-                  <a:srgbClr val="AFAFAF"/>
-                </a:solidFill>
-              </a:rPr>
-              <a:t>4.4  </a:t>
-            </a:r>
-            <a:r>
-              <a:t>첫 지시 문장</a:t>
-            </a:r>
-          </a:p>
-          <a:p>
-            <a:pPr>
-              <a:spcAft>
-                <a:spcPts val="1000"/>
-              </a:spcAft>
-            </a:pPr>
-            <a:r>
-              <a:rPr>
-                <a:solidFill>
-                  <a:srgbClr val="AFAFAF"/>
-                </a:solidFill>
-              </a:rPr>
-              <a:t>4.5  </a:t>
-            </a:r>
-            <a:r>
-              <a:t>에이전트가 판단할 수 없는 것</a:t>
-            </a:r>
-          </a:p>
-        </p:txBody>
-      </p:sp>
-    </p:spTree>
-  </p:cSld>
-  <p:clrMapOvr>
-    <a:masterClrMapping/>
-  </p:clrMapOvr>
-</p:sld>
-</file>
-
 <file path=ppt/slides/slide18.xml><?xml version="1.0" encoding="utf-8"?>
 <p:sld xmlns:a="http://schemas.openxmlformats.org/drawingml/2006/main" xmlns:p="http://schemas.openxmlformats.org/presentationml/2006/main" xmlns:r="http://schemas.openxmlformats.org/officeDocument/2006/relationships">
   <p:cSld>
@@ -7886,42 +7898,42 @@
       <p:grpSpPr/>
       <p:sp>
         <p:nvSpPr>
-          <p:cNvPr id="2" name="Title 1"/>
-          <p:cNvSpPr>
-            <a:spLocks noGrp="1"/>
-          </p:cNvSpPr>
-          <p:nvPr>
-            <p:ph type="title" idx="100"/>
-          </p:nvPr>
-        </p:nvSpPr>
-        <p:spPr/>
-        <p:txBody>
-          <a:bodyPr/>
-          <a:lstStyle/>
-          <a:p>
-            <a:r>
-              <a:t>4.1 에이전트를 여는 위치</a:t>
-            </a:r>
-          </a:p>
-        </p:txBody>
-      </p:sp>
-      <p:sp>
-        <p:nvSpPr>
-          <p:cNvPr id="3" name="Text Placeholder 2"/>
-          <p:cNvSpPr>
-            <a:spLocks noGrp="1"/>
-          </p:cNvSpPr>
-          <p:nvPr>
-            <p:ph type="body" idx="101"/>
-          </p:nvPr>
-        </p:nvSpPr>
-        <p:spPr/>
-        <p:txBody>
-          <a:bodyPr/>
-          <a:lstStyle/>
-          <a:p>
-            <a:r>
-              <a:t>4. 에이전트 실행과 권한</a:t>
+          <p:cNvPr id="2" name="Text Placeholder 1"/>
+          <p:cNvSpPr>
+            <a:spLocks noGrp="1"/>
+          </p:cNvSpPr>
+          <p:nvPr>
+            <p:ph type="body" idx="100"/>
+          </p:nvPr>
+        </p:nvSpPr>
+        <p:spPr/>
+        <p:txBody>
+          <a:bodyPr/>
+          <a:lstStyle/>
+          <a:p>
+            <a:r>
+              <a:t>04</a:t>
+            </a:r>
+          </a:p>
+        </p:txBody>
+      </p:sp>
+      <p:sp>
+        <p:nvSpPr>
+          <p:cNvPr id="3" name="Title 2"/>
+          <p:cNvSpPr>
+            <a:spLocks noGrp="1"/>
+          </p:cNvSpPr>
+          <p:nvPr>
+            <p:ph type="title" idx="101"/>
+          </p:nvPr>
+        </p:nvSpPr>
+        <p:spPr/>
+        <p:txBody>
+          <a:bodyPr/>
+          <a:lstStyle/>
+          <a:p>
+            <a:r>
+              <a:t>에이전트 실행과 권한</a:t>
             </a:r>
           </a:p>
         </p:txBody>
@@ -7941,76 +7953,94 @@
           <a:bodyPr/>
           <a:lstStyle/>
           <a:p>
-            <a:pPr/>
-            <a:r>
-              <a:t>실행 위치: 프로젝트 폴더에서 터미널 실행 → 해당 폴더가 작업 범위</a:t>
-            </a:r>
-          </a:p>
-          <a:p>
-            <a:pPr/>
-            <a:r>
-              <a:t>VS Code: 터미널 메뉴에서 새 터미널 열기</a:t>
-            </a:r>
-          </a:p>
-          <a:p>
-            <a:pPr/>
-            <a:r>
-              <a:t>첫 확인: 현재 경로와 파일 목록을 먼저 출력</a:t>
-            </a:r>
-          </a:p>
-          <a:p>
-            <a:pPr/>
-            <a:r>
-              <a:t>주의 사항: 홈 폴더나 바탕화면에서 실행하지 않기</a:t>
-            </a:r>
-          </a:p>
-        </p:txBody>
-      </p:sp>
-      <p:sp>
-        <p:nvSpPr>
-          <p:cNvPr id="25" name="Slide Number Placeholder 0"/>
-          <p:cNvSpPr>
-            <a:spLocks noGrp="1"/>
-          </p:cNvSpPr>
-          <p:nvPr>
-            <p:ph type="sldNum" sz="quarter" idx="4294967295"/>
-          </p:nvPr>
-        </p:nvSpPr>
-        <p:spPr>
-          <a:xfrm>
-            <a:off x="10591495" y="6355080"/>
-            <a:ext cx="914400" cy="274320"/>
-          </a:xfrm>
-          <a:prstGeom prst="rect">
-            <a:avLst/>
-          </a:prstGeom>
-          <a:extLst>
-            <a:ext uri="{C572A759-6A51-4108-AA02-DFA0A04FC94B}">
-              <ma14:wrappingTextBoxFlag xmlns:ma14="http://schemas.microsoft.com/office/mac/drawingml/2011/main" val="0"/>
-            </a:ext>
-          </a:extLst>
-        </p:spPr>
-        <p:txBody>
-          <a:bodyPr/>
-          <a:lstStyle>
-            <a:lvl1pPr>
-              <a:defRPr sz="1000">
+            <a:pPr>
+              <a:spcAft>
+                <a:spcPts val="1000"/>
+              </a:spcAft>
+            </a:pPr>
+            <a:r>
+              <a:rPr>
                 <a:solidFill>
                   <a:srgbClr val="AFAFAF"/>
                 </a:solidFill>
-                <a:latin typeface="Pretendard Medium"/>
-                <a:ea typeface="Pretendard Medium"/>
-                <a:cs typeface="Pretendard Medium"/>
-              </a:defRPr>
-            </a:lvl1pPr>
-          </a:lstStyle>
-          <a:p>
-            <a:pPr algn="r"/>
-            <a:fld id="{F7021451-1387-4CA6-816F-3879F97B5CBC}" type="slidenum">
-              <a:rPr b="0" lang="en-US"/>
-              <a:t>1004</a:t>
-            </a:fld>
-            <a:endParaRPr lang="en-US"/>
+              </a:rPr>
+              <a:t>4.1  </a:t>
+            </a:r>
+            <a:r>
+              <a:t>에이전트를 여는 위치</a:t>
+            </a:r>
+          </a:p>
+          <a:p>
+            <a:pPr>
+              <a:spcAft>
+                <a:spcPts val="1000"/>
+              </a:spcAft>
+            </a:pPr>
+            <a:r>
+              <a:rPr>
+                <a:solidFill>
+                  <a:srgbClr val="AFAFAF"/>
+                </a:solidFill>
+              </a:rPr>
+              <a:t>4.2  </a:t>
+            </a:r>
+            <a:r>
+              <a:t>권한 모드 세 단계</a:t>
+            </a:r>
+          </a:p>
+          <a:p>
+            <a:pPr>
+              <a:spcAft>
+                <a:spcPts val="1000"/>
+              </a:spcAft>
+            </a:pPr>
+            <a:r>
+              <a:rPr>
+                <a:solidFill>
+                  <a:srgbClr val="AFAFAF"/>
+                </a:solidFill>
+              </a:rPr>
+              <a:t>4.3  </a:t>
+            </a:r>
+            <a:r>
+              <a:t>Git 커밋과 복구</a:t>
+            </a:r>
+          </a:p>
+          <a:p>
+            <a:pPr>
+              <a:spcAft>
+                <a:spcPts val="1000"/>
+              </a:spcAft>
+            </a:pPr>
+            <a:r>
+              <a:rPr>
+                <a:solidFill>
+                  <a:srgbClr val="AFAFAF"/>
+                </a:solidFill>
+              </a:rPr>
+              <a:t>4.4  </a:t>
+            </a:r>
+            <a:r>
+              <a:t>전면 자동을 쓰는 조건</a:t>
+            </a:r>
+          </a:p>
+          <a:p>
+            <a:pPr>
+              <a:spcAft>
+                <a:spcPts val="1000"/>
+              </a:spcAft>
+            </a:pPr>
+            <a:r>
+              <a:rPr>
+                <a:solidFill>
+                  <a:srgbClr val="AFAFAF"/>
+                </a:solidFill>
+              </a:rPr>
+              <a:t>4.5  </a:t>
+            </a:r>
+            <a:r>
+              <a:t>에이전트가 판단할 수 없는 것</a:t>
+            </a:r>
           </a:p>
         </p:txBody>
       </p:sp>
@@ -8048,7 +8078,7 @@
           <a:lstStyle/>
           <a:p>
             <a:r>
-              <a:t>4.2 권한 모드 세 단계</a:t>
+              <a:t>4.1 에이전트를 여는 위치</a:t>
             </a:r>
           </a:p>
         </p:txBody>
@@ -8091,648 +8121,29 @@
           <a:p>
             <a:pPr/>
             <a:r>
-              <a:t>전환 방법: Claude Code는 Shift+Tab · Codex는 /approvals · Antigravity는 설정 화면</a:t>
+              <a:t>실행 위치: 프로젝트 폴더에서 터미널 실행 → 해당 폴더가 작업 범위</a:t>
             </a:r>
           </a:p>
           <a:p>
             <a:pPr/>
             <a:r>
-              <a:t>시작 옵션: claude --dangerously-skip-permissions · codex --yolo</a:t>
+              <a:t>VS Code: 터미널 메뉴에서 새 터미널 열기</a:t>
             </a:r>
           </a:p>
           <a:p>
             <a:pPr/>
             <a:r>
-              <a:t>계획 우선 실행: Claude Code의 plan 모드는 파일을 수정하지 않고 계획만 제시</a:t>
-            </a:r>
-          </a:p>
-        </p:txBody>
-      </p:sp>
-      <p:sp>
-        <p:nvSpPr>
-          <p:cNvPr id="5" name="Text Placeholder 4"/>
-          <p:cNvSpPr>
-            <a:spLocks noGrp="1"/>
-          </p:cNvSpPr>
-          <p:nvPr>
-            <p:ph type="body" idx="103"/>
-          </p:nvPr>
-        </p:nvSpPr>
-        <p:spPr/>
-        <p:txBody>
-          <a:bodyPr/>
-          <a:lstStyle/>
-          <a:p>
-            <a:r>
-              <a:t>표 2. 도구별 권한 단계와 설정 이름</a:t>
-            </a:r>
-          </a:p>
-        </p:txBody>
-      </p:sp>
-      <p:graphicFrame>
-        <p:nvGraphicFramePr>
-          <p:cNvPr id="6" name="Table Placeholder 5"/>
-          <p:cNvGraphicFramePr>
-            <a:graphicFrameLocks noGrp="1"/>
-          </p:cNvGraphicFramePr>
-          <p:nvPr>
-            <p:ph type="tbl" idx="104"/>
-          </p:nvPr>
-        </p:nvGraphicFramePr>
-        <p:xfrm>
-          <a:off x="4937760" y="1828800"/>
-          <a:ext cx="6565392" cy="2311400"/>
-        </p:xfrm>
-        <a:graphic>
-          <a:graphicData uri="http://schemas.openxmlformats.org/drawingml/2006/table">
-            <a:tbl>
-              <a:tblPr firstRow="0" bandRow="0" firstCol="0" lastRow="0" lastCol="0" bandCol="0"/>
-              <a:tblGrid>
-                <a:gridCol w="1641348"/>
-                <a:gridCol w="1641348"/>
-                <a:gridCol w="1641348"/>
-                <a:gridCol w="1641348"/>
-              </a:tblGrid>
-              <a:tr h="406400">
-                <a:tc>
-                  <a:txBody>
-                    <a:bodyPr/>
-                    <a:lstStyle/>
-                    <a:p>
-                      <a:r>
-                        <a:rPr sz="1300" b="0">
-                          <a:solidFill>
-                            <a:srgbClr val="FFFFFF"/>
-                          </a:solidFill>
-                          <a:latin typeface="Pretendard Medium"/>
-                        </a:rPr>
-                        <a:t>도구</a:t>
-                      </a:r>
-                    </a:p>
-                  </a:txBody>
-                  <a:tcPr marL="101600" marR="101600" marT="76200" marB="76200" anchor="ctr">
-                    <a:solidFill>
-                      <a:srgbClr val="000000"/>
-                    </a:solidFill>
-                    <a:lnL w="0">
-                      <a:noFill/>
-                    </a:lnL>
-                    <a:lnR w="0">
-                      <a:noFill/>
-                    </a:lnR>
-                    <a:lnT w="0">
-                      <a:noFill/>
-                    </a:lnT>
-                    <a:lnB w="0">
-                      <a:noFill/>
-                    </a:lnB>
-                  </a:tcPr>
-                </a:tc>
-                <a:tc>
-                  <a:txBody>
-                    <a:bodyPr/>
-                    <a:lstStyle/>
-                    <a:p>
-                      <a:r>
-                        <a:rPr sz="1300" b="0">
-                          <a:solidFill>
-                            <a:srgbClr val="FFFFFF"/>
-                          </a:solidFill>
-                          <a:latin typeface="Pretendard Medium"/>
-                        </a:rPr>
-                        <a:t>매번 승인</a:t>
-                      </a:r>
-                    </a:p>
-                  </a:txBody>
-                  <a:tcPr marL="101600" marR="101600" marT="76200" marB="76200" anchor="ctr">
-                    <a:solidFill>
-                      <a:srgbClr val="000000"/>
-                    </a:solidFill>
-                    <a:lnL w="0">
-                      <a:noFill/>
-                    </a:lnL>
-                    <a:lnR w="0">
-                      <a:noFill/>
-                    </a:lnR>
-                    <a:lnT w="0">
-                      <a:noFill/>
-                    </a:lnT>
-                    <a:lnB w="0">
-                      <a:noFill/>
-                    </a:lnB>
-                  </a:tcPr>
-                </a:tc>
-                <a:tc>
-                  <a:txBody>
-                    <a:bodyPr/>
-                    <a:lstStyle/>
-                    <a:p>
-                      <a:r>
-                        <a:rPr sz="1300" b="0">
-                          <a:solidFill>
-                            <a:srgbClr val="FFFFFF"/>
-                          </a:solidFill>
-                          <a:latin typeface="Pretendard Medium"/>
-                        </a:rPr>
-                        <a:t>부분 자동</a:t>
-                      </a:r>
-                    </a:p>
-                  </a:txBody>
-                  <a:tcPr marL="101600" marR="101600" marT="76200" marB="76200" anchor="ctr">
-                    <a:solidFill>
-                      <a:srgbClr val="000000"/>
-                    </a:solidFill>
-                    <a:lnL w="0">
-                      <a:noFill/>
-                    </a:lnL>
-                    <a:lnR w="0">
-                      <a:noFill/>
-                    </a:lnR>
-                    <a:lnT w="0">
-                      <a:noFill/>
-                    </a:lnT>
-                    <a:lnB w="0">
-                      <a:noFill/>
-                    </a:lnB>
-                  </a:tcPr>
-                </a:tc>
-                <a:tc>
-                  <a:txBody>
-                    <a:bodyPr/>
-                    <a:lstStyle/>
-                    <a:p>
-                      <a:r>
-                        <a:rPr sz="1300" b="0">
-                          <a:solidFill>
-                            <a:srgbClr val="FFFFFF"/>
-                          </a:solidFill>
-                          <a:latin typeface="Pretendard Medium"/>
-                        </a:rPr>
-                        <a:t>전면 자동</a:t>
-                      </a:r>
-                    </a:p>
-                  </a:txBody>
-                  <a:tcPr marL="101600" marR="101600" marT="76200" marB="76200" anchor="ctr">
-                    <a:solidFill>
-                      <a:srgbClr val="000000"/>
-                    </a:solidFill>
-                    <a:lnL w="0">
-                      <a:noFill/>
-                    </a:lnL>
-                    <a:lnR w="0">
-                      <a:noFill/>
-                    </a:lnR>
-                    <a:lnT w="0">
-                      <a:noFill/>
-                    </a:lnT>
-                    <a:lnB w="0">
-                      <a:noFill/>
-                    </a:lnB>
-                  </a:tcPr>
-                </a:tc>
-              </a:tr>
-              <a:tr h="635000">
-                <a:tc>
-                  <a:txBody>
-                    <a:bodyPr/>
-                    <a:lstStyle/>
-                    <a:p>
-                      <a:r>
-                        <a:rPr sz="1300" b="1">
-                          <a:solidFill>
-                            <a:srgbClr val="000000"/>
-                          </a:solidFill>
-                          <a:latin typeface="Pretendard"/>
-                        </a:rPr>
-                        <a:t>Claude Code</a:t>
-                      </a:r>
-                    </a:p>
-                  </a:txBody>
-                  <a:tcPr marL="101600" marR="101600" marT="101600" marB="101600" anchor="ctr">
-                    <a:solidFill>
-                      <a:srgbClr val="FFFFFF"/>
-                    </a:solidFill>
-                    <a:lnL w="0">
-                      <a:noFill/>
-                    </a:lnL>
-                    <a:lnR w="0">
-                      <a:noFill/>
-                    </a:lnR>
-                    <a:lnT w="0">
-                      <a:noFill/>
-                    </a:lnT>
-                    <a:lnB w="9525">
-                      <a:solidFill>
-                        <a:srgbClr val="E2E2E2"/>
-                      </a:solidFill>
-                    </a:lnB>
-                  </a:tcPr>
-                </a:tc>
-                <a:tc>
-                  <a:txBody>
-                    <a:bodyPr/>
-                    <a:lstStyle/>
-                    <a:p>
-                      <a:r>
-                        <a:rPr sz="1300" b="0">
-                          <a:solidFill>
-                            <a:srgbClr val="5E5E5E"/>
-                          </a:solidFill>
-                          <a:latin typeface="Pretendard Medium"/>
-                        </a:rPr>
-                        <a:t>기본 모드</a:t>
-                      </a:r>
-                    </a:p>
-                  </a:txBody>
-                  <a:tcPr marL="101600" marR="101600" marT="101600" marB="101600" anchor="ctr">
-                    <a:solidFill>
-                      <a:srgbClr val="FFFFFF"/>
-                    </a:solidFill>
-                    <a:lnL w="0">
-                      <a:noFill/>
-                    </a:lnL>
-                    <a:lnR w="0">
-                      <a:noFill/>
-                    </a:lnR>
-                    <a:lnT w="0">
-                      <a:noFill/>
-                    </a:lnT>
-                    <a:lnB w="9525">
-                      <a:solidFill>
-                        <a:srgbClr val="E2E2E2"/>
-                      </a:solidFill>
-                    </a:lnB>
-                  </a:tcPr>
-                </a:tc>
-                <a:tc>
-                  <a:txBody>
-                    <a:bodyPr/>
-                    <a:lstStyle/>
-                    <a:p>
-                      <a:r>
-                        <a:rPr sz="1300" b="0">
-                          <a:solidFill>
-                            <a:srgbClr val="5E5E5E"/>
-                          </a:solidFill>
-                          <a:latin typeface="Pretendard Medium"/>
-                        </a:rPr>
-                        <a:t>acceptEdits</a:t>
-                      </a:r>
-                    </a:p>
-                  </a:txBody>
-                  <a:tcPr marL="101600" marR="101600" marT="101600" marB="101600" anchor="ctr">
-                    <a:solidFill>
-                      <a:srgbClr val="FFFFFF"/>
-                    </a:solidFill>
-                    <a:lnL w="0">
-                      <a:noFill/>
-                    </a:lnL>
-                    <a:lnR w="0">
-                      <a:noFill/>
-                    </a:lnR>
-                    <a:lnT w="0">
-                      <a:noFill/>
-                    </a:lnT>
-                    <a:lnB w="9525">
-                      <a:solidFill>
-                        <a:srgbClr val="E2E2E2"/>
-                      </a:solidFill>
-                    </a:lnB>
-                  </a:tcPr>
-                </a:tc>
-                <a:tc>
-                  <a:txBody>
-                    <a:bodyPr/>
-                    <a:lstStyle/>
-                    <a:p>
-                      <a:r>
-                        <a:rPr sz="1300" b="0">
-                          <a:solidFill>
-                            <a:srgbClr val="5E5E5E"/>
-                          </a:solidFill>
-                          <a:latin typeface="Pretendard Medium"/>
-                        </a:rPr>
-                        <a:t>bypassPermissions</a:t>
-                      </a:r>
-                    </a:p>
-                  </a:txBody>
-                  <a:tcPr marL="101600" marR="101600" marT="101600" marB="101600" anchor="ctr">
-                    <a:solidFill>
-                      <a:srgbClr val="FFFFFF"/>
-                    </a:solidFill>
-                    <a:lnL w="0">
-                      <a:noFill/>
-                    </a:lnL>
-                    <a:lnR w="0">
-                      <a:noFill/>
-                    </a:lnR>
-                    <a:lnT w="0">
-                      <a:noFill/>
-                    </a:lnT>
-                    <a:lnB w="9525">
-                      <a:solidFill>
-                        <a:srgbClr val="E2E2E2"/>
-                      </a:solidFill>
-                    </a:lnB>
-                  </a:tcPr>
-                </a:tc>
-              </a:tr>
-              <a:tr h="635000">
-                <a:tc>
-                  <a:txBody>
-                    <a:bodyPr/>
-                    <a:lstStyle/>
-                    <a:p>
-                      <a:r>
-                        <a:rPr sz="1300" b="1">
-                          <a:solidFill>
-                            <a:srgbClr val="000000"/>
-                          </a:solidFill>
-                          <a:latin typeface="Pretendard"/>
-                        </a:rPr>
-                        <a:t>Codex</a:t>
-                      </a:r>
-                    </a:p>
-                  </a:txBody>
-                  <a:tcPr marL="101600" marR="101600" marT="101600" marB="101600" anchor="ctr">
-                    <a:solidFill>
-                      <a:srgbClr val="FFFFFF"/>
-                    </a:solidFill>
-                    <a:lnL w="0">
-                      <a:noFill/>
-                    </a:lnL>
-                    <a:lnR w="0">
-                      <a:noFill/>
-                    </a:lnR>
-                    <a:lnT w="0">
-                      <a:noFill/>
-                    </a:lnT>
-                    <a:lnB w="9525">
-                      <a:solidFill>
-                        <a:srgbClr val="E2E2E2"/>
-                      </a:solidFill>
-                    </a:lnB>
-                  </a:tcPr>
-                </a:tc>
-                <a:tc>
-                  <a:txBody>
-                    <a:bodyPr/>
-                    <a:lstStyle/>
-                    <a:p>
-                      <a:r>
-                        <a:rPr sz="1300" b="0">
-                          <a:solidFill>
-                            <a:srgbClr val="5E5E5E"/>
-                          </a:solidFill>
-                          <a:latin typeface="Pretendard Medium"/>
-                        </a:rPr>
-                        <a:t>ask-for-approval</a:t>
-                      </a:r>
-                    </a:p>
-                  </a:txBody>
-                  <a:tcPr marL="101600" marR="101600" marT="101600" marB="101600" anchor="ctr">
-                    <a:solidFill>
-                      <a:srgbClr val="FFFFFF"/>
-                    </a:solidFill>
-                    <a:lnL w="0">
-                      <a:noFill/>
-                    </a:lnL>
-                    <a:lnR w="0">
-                      <a:noFill/>
-                    </a:lnR>
-                    <a:lnT w="0">
-                      <a:noFill/>
-                    </a:lnT>
-                    <a:lnB w="9525">
-                      <a:solidFill>
-                        <a:srgbClr val="E2E2E2"/>
-                      </a:solidFill>
-                    </a:lnB>
-                  </a:tcPr>
-                </a:tc>
-                <a:tc>
-                  <a:txBody>
-                    <a:bodyPr/>
-                    <a:lstStyle/>
-                    <a:p>
-                      <a:r>
-                        <a:rPr sz="1300" b="0">
-                          <a:solidFill>
-                            <a:srgbClr val="5E5E5E"/>
-                          </a:solidFill>
-                          <a:latin typeface="Pretendard Medium"/>
-                        </a:rPr>
-                        <a:t>full-auto</a:t>
-                      </a:r>
-                    </a:p>
-                  </a:txBody>
-                  <a:tcPr marL="101600" marR="101600" marT="101600" marB="101600" anchor="ctr">
-                    <a:solidFill>
-                      <a:srgbClr val="FFFFFF"/>
-                    </a:solidFill>
-                    <a:lnL w="0">
-                      <a:noFill/>
-                    </a:lnL>
-                    <a:lnR w="0">
-                      <a:noFill/>
-                    </a:lnR>
-                    <a:lnT w="0">
-                      <a:noFill/>
-                    </a:lnT>
-                    <a:lnB w="9525">
-                      <a:solidFill>
-                        <a:srgbClr val="E2E2E2"/>
-                      </a:solidFill>
-                    </a:lnB>
-                  </a:tcPr>
-                </a:tc>
-                <a:tc>
-                  <a:txBody>
-                    <a:bodyPr/>
-                    <a:lstStyle/>
-                    <a:p>
-                      <a:r>
-                        <a:rPr sz="1300" b="0">
-                          <a:solidFill>
-                            <a:srgbClr val="5E5E5E"/>
-                          </a:solidFill>
-                          <a:latin typeface="Pretendard Medium"/>
-                        </a:rPr>
-                        <a:t>yolo</a:t>
-                      </a:r>
-                    </a:p>
-                  </a:txBody>
-                  <a:tcPr marL="101600" marR="101600" marT="101600" marB="101600" anchor="ctr">
-                    <a:solidFill>
-                      <a:srgbClr val="FFFFFF"/>
-                    </a:solidFill>
-                    <a:lnL w="0">
-                      <a:noFill/>
-                    </a:lnL>
-                    <a:lnR w="0">
-                      <a:noFill/>
-                    </a:lnR>
-                    <a:lnT w="0">
-                      <a:noFill/>
-                    </a:lnT>
-                    <a:lnB w="9525">
-                      <a:solidFill>
-                        <a:srgbClr val="E2E2E2"/>
-                      </a:solidFill>
-                    </a:lnB>
-                  </a:tcPr>
-                </a:tc>
-              </a:tr>
-              <a:tr h="635000">
-                <a:tc>
-                  <a:txBody>
-                    <a:bodyPr/>
-                    <a:lstStyle/>
-                    <a:p>
-                      <a:r>
-                        <a:rPr sz="1300" b="1">
-                          <a:solidFill>
-                            <a:srgbClr val="000000"/>
-                          </a:solidFill>
-                          <a:latin typeface="Pretendard"/>
-                        </a:rPr>
-                        <a:t>Antigravity</a:t>
-                      </a:r>
-                    </a:p>
-                  </a:txBody>
-                  <a:tcPr marL="101600" marR="101600" marT="101600" marB="101600" anchor="ctr">
-                    <a:solidFill>
-                      <a:srgbClr val="FFFFFF"/>
-                    </a:solidFill>
-                    <a:lnL w="0">
-                      <a:noFill/>
-                    </a:lnL>
-                    <a:lnR w="0">
-                      <a:noFill/>
-                    </a:lnR>
-                    <a:lnT w="0">
-                      <a:noFill/>
-                    </a:lnT>
-                    <a:lnB w="9525">
-                      <a:solidFill>
-                        <a:srgbClr val="E2E2E2"/>
-                      </a:solidFill>
-                    </a:lnB>
-                  </a:tcPr>
-                </a:tc>
-                <a:tc>
-                  <a:txBody>
-                    <a:bodyPr/>
-                    <a:lstStyle/>
-                    <a:p>
-                      <a:r>
-                        <a:rPr sz="1300" b="0">
-                          <a:solidFill>
-                            <a:srgbClr val="5E5E5E"/>
-                          </a:solidFill>
-                          <a:latin typeface="Pretendard Medium"/>
-                        </a:rPr>
-                        <a:t>Request Review</a:t>
-                      </a:r>
-                    </a:p>
-                  </a:txBody>
-                  <a:tcPr marL="101600" marR="101600" marT="101600" marB="101600" anchor="ctr">
-                    <a:solidFill>
-                      <a:srgbClr val="FFFFFF"/>
-                    </a:solidFill>
-                    <a:lnL w="0">
-                      <a:noFill/>
-                    </a:lnL>
-                    <a:lnR w="0">
-                      <a:noFill/>
-                    </a:lnR>
-                    <a:lnT w="0">
-                      <a:noFill/>
-                    </a:lnT>
-                    <a:lnB w="9525">
-                      <a:solidFill>
-                        <a:srgbClr val="E2E2E2"/>
-                      </a:solidFill>
-                    </a:lnB>
-                  </a:tcPr>
-                </a:tc>
-                <a:tc>
-                  <a:txBody>
-                    <a:bodyPr/>
-                    <a:lstStyle/>
-                    <a:p>
-                      <a:r>
-                        <a:rPr sz="1300" b="0">
-                          <a:solidFill>
-                            <a:srgbClr val="5E5E5E"/>
-                          </a:solidFill>
-                          <a:latin typeface="Pretendard Medium"/>
-                        </a:rPr>
-                        <a:t>Proceed in Sandbox</a:t>
-                      </a:r>
-                    </a:p>
-                  </a:txBody>
-                  <a:tcPr marL="101600" marR="101600" marT="101600" marB="101600" anchor="ctr">
-                    <a:solidFill>
-                      <a:srgbClr val="FFFFFF"/>
-                    </a:solidFill>
-                    <a:lnL w="0">
-                      <a:noFill/>
-                    </a:lnL>
-                    <a:lnR w="0">
-                      <a:noFill/>
-                    </a:lnR>
-                    <a:lnT w="0">
-                      <a:noFill/>
-                    </a:lnT>
-                    <a:lnB w="9525">
-                      <a:solidFill>
-                        <a:srgbClr val="E2E2E2"/>
-                      </a:solidFill>
-                    </a:lnB>
-                  </a:tcPr>
-                </a:tc>
-                <a:tc>
-                  <a:txBody>
-                    <a:bodyPr/>
-                    <a:lstStyle/>
-                    <a:p>
-                      <a:r>
-                        <a:rPr sz="1300" b="0">
-                          <a:solidFill>
-                            <a:srgbClr val="5E5E5E"/>
-                          </a:solidFill>
-                          <a:latin typeface="Pretendard Medium"/>
-                        </a:rPr>
-                        <a:t>Always Proceed</a:t>
-                      </a:r>
-                    </a:p>
-                  </a:txBody>
-                  <a:tcPr marL="101600" marR="101600" marT="101600" marB="101600" anchor="ctr">
-                    <a:solidFill>
-                      <a:srgbClr val="FFFFFF"/>
-                    </a:solidFill>
-                    <a:lnL w="0">
-                      <a:noFill/>
-                    </a:lnL>
-                    <a:lnR w="0">
-                      <a:noFill/>
-                    </a:lnR>
-                    <a:lnT w="0">
-                      <a:noFill/>
-                    </a:lnT>
-                    <a:lnB w="9525">
-                      <a:solidFill>
-                        <a:srgbClr val="E2E2E2"/>
-                      </a:solidFill>
-                    </a:lnB>
-                  </a:tcPr>
-                </a:tc>
-              </a:tr>
-            </a:tbl>
-          </a:graphicData>
-        </a:graphic>
-      </p:graphicFrame>
+              <a:t>첫 확인: 현재 경로와 파일 목록을 먼저 출력</a:t>
+            </a:r>
+          </a:p>
+          <a:p>
+            <a:pPr/>
+            <a:r>
+              <a:t>주의 사항: 홈 폴더나 바탕화면에서 실행하지 않기</a:t>
+            </a:r>
+          </a:p>
+        </p:txBody>
+      </p:sp>
       <p:sp>
         <p:nvSpPr>
           <p:cNvPr id="25" name="Slide Number Placeholder 0"/>
@@ -8775,7 +8186,7 @@
             <a:pPr algn="r"/>
             <a:fld id="{F7021451-1387-4CA6-816F-3879F97B5CBC}" type="slidenum">
               <a:rPr b="0" lang="en-US"/>
-              <a:t>1008</a:t>
+              <a:t>1004</a:t>
             </a:fld>
             <a:endParaRPr lang="en-US"/>
           </a:p>
@@ -9169,7 +8580,7 @@
                           </a:solidFill>
                           <a:latin typeface="Pretendard Medium"/>
                         </a:rPr>
-                        <a:t>3.1 도구별 역할  ·  3.2 Claude Code 설치  ·  3.3 Codex 설치  ·  3.4 Antigravity 설치  ·  3.5 계정과 사용 한도</a:t>
+                        <a:t>3.1 도구별 역할  ·  3.2 Claude Code 설치  ·  3.3 Codex 설치  ·  3.4 Antigravity 편집기 설치  ·  3.5 Antigravity CLI 설치  ·  3.6 계정과 사용 한도</a:t>
                       </a:r>
                     </a:p>
                   </a:txBody>
@@ -9279,7 +8690,7 @@
                           </a:solidFill>
                           <a:latin typeface="Pretendard Medium"/>
                         </a:rPr>
-                        <a:t>4.1 에이전트를 여는 위치  ·  4.2 권한 모드 세 단계  ·  4.3 전면 자동을 쓰는 조건  ·  4.4 첫 지시 문장  ·  4.5 에이전트가 판단할 수 없는 것</a:t>
+                        <a:t>4.1 에이전트를 여는 위치  ·  4.2 권한 모드 세 단계  ·  4.3 Git 커밋과 복구  ·  4.4 전면 자동을 쓰는 조건  ·  4.5 에이전트가 판단할 수 없는 것</a:t>
                       </a:r>
                     </a:p>
                   </a:txBody>
@@ -9353,7 +8764,7 @@
                           </a:solidFill>
                           <a:latin typeface="Pretendard"/>
                         </a:rPr>
-                        <a:t>확인과 기록</a:t>
+                        <a:t>명령과 기록</a:t>
                       </a:r>
                     </a:p>
                   </a:txBody>
@@ -9389,7 +8800,7 @@
                           </a:solidFill>
                           <a:latin typeface="Pretendard Medium"/>
                         </a:rPr>
-                        <a:t>5.1 결과 확인 항목  ·  5.2 자주 쓰는 명령  ·  5.3 대화를 비우는 기준  ·  5.4 모델 선택  ·  5.5 md 파일로 남기는 맥락</a:t>
+                        <a:t>5.1 자주 쓰는 명령  ·  5.2 대화를 비우는 기준  ·  5.3 모델 선택  ·  5.4 md 파일로 남기는 맥락</a:t>
                       </a:r>
                     </a:p>
                   </a:txBody>
@@ -9610,7 +9021,7 @@
           <a:lstStyle/>
           <a:p>
             <a:r>
-              <a:t>4.3 전면 자동을 쓰는 조건</a:t>
+              <a:t>4.2 권한 모드 세 단계</a:t>
             </a:r>
           </a:p>
         </p:txBody>
@@ -9653,29 +9064,794 @@
           <a:p>
             <a:pPr/>
             <a:r>
-              <a:t>조건 1: Git 저장소이고 직전 작업까지 커밋된 상태</a:t>
+              <a:t>전환 방법: Claude Code는 Shift+Tab · Codex는 /approvals · Antigravity CLI는 /permissions</a:t>
             </a:r>
           </a:p>
           <a:p>
             <a:pPr/>
             <a:r>
-              <a:t>조건 2: 과제나 실습 폴더 — 개인 자료와 자격증명이 없는 위치</a:t>
+              <a:t>전면 자동 시작 옵션: claude --dangerously-skip-permissions · codex --yolo · agy --dangerously-skip-permissions</a:t>
             </a:r>
           </a:p>
           <a:p>
             <a:pPr/>
             <a:r>
-              <a:t>조건 3: 결과 확인 방법을 미리 정해 둔 경우</a:t>
-            </a:r>
-          </a:p>
-          <a:p>
-            <a:pPr/>
-            <a:r>
-              <a:t>제외 대상: 홈 폴더, 연구실 공용 저장소, 자격증명이 있는 폴더</a:t>
-            </a:r>
-          </a:p>
-        </p:txBody>
-      </p:sp>
+              <a:t>계획 우선 실행: Claude Code의 plan 모드는 파일을 수정하지 않고 계획만 제시</a:t>
+            </a:r>
+          </a:p>
+        </p:txBody>
+      </p:sp>
+      <p:sp>
+        <p:nvSpPr>
+          <p:cNvPr id="5" name="Text Placeholder 4"/>
+          <p:cNvSpPr>
+            <a:spLocks noGrp="1"/>
+          </p:cNvSpPr>
+          <p:nvPr>
+            <p:ph type="body" idx="103"/>
+          </p:nvPr>
+        </p:nvSpPr>
+        <p:spPr/>
+        <p:txBody>
+          <a:bodyPr/>
+          <a:lstStyle/>
+          <a:p>
+            <a:r>
+              <a:t>표 2. 도구별 권한 단계와 설정 이름</a:t>
+            </a:r>
+          </a:p>
+        </p:txBody>
+      </p:sp>
+      <p:graphicFrame>
+        <p:nvGraphicFramePr>
+          <p:cNvPr id="6" name="Table Placeholder 5"/>
+          <p:cNvGraphicFramePr>
+            <a:graphicFrameLocks noGrp="1"/>
+          </p:cNvGraphicFramePr>
+          <p:nvPr>
+            <p:ph type="tbl" idx="104"/>
+          </p:nvPr>
+        </p:nvGraphicFramePr>
+        <p:xfrm>
+          <a:off x="4937760" y="1828800"/>
+          <a:ext cx="6565392" cy="2946400"/>
+        </p:xfrm>
+        <a:graphic>
+          <a:graphicData uri="http://schemas.openxmlformats.org/drawingml/2006/table">
+            <a:tbl>
+              <a:tblPr firstRow="0" bandRow="0" firstCol="0" lastRow="0" lastCol="0" bandCol="0"/>
+              <a:tblGrid>
+                <a:gridCol w="1641348"/>
+                <a:gridCol w="1641348"/>
+                <a:gridCol w="1641348"/>
+                <a:gridCol w="1641348"/>
+              </a:tblGrid>
+              <a:tr h="406400">
+                <a:tc>
+                  <a:txBody>
+                    <a:bodyPr/>
+                    <a:lstStyle/>
+                    <a:p>
+                      <a:r>
+                        <a:rPr sz="1300" b="0">
+                          <a:solidFill>
+                            <a:srgbClr val="FFFFFF"/>
+                          </a:solidFill>
+                          <a:latin typeface="Pretendard Medium"/>
+                        </a:rPr>
+                        <a:t>도구</a:t>
+                      </a:r>
+                    </a:p>
+                  </a:txBody>
+                  <a:tcPr marL="101600" marR="101600" marT="76200" marB="76200" anchor="ctr">
+                    <a:solidFill>
+                      <a:srgbClr val="000000"/>
+                    </a:solidFill>
+                    <a:lnL w="0">
+                      <a:noFill/>
+                    </a:lnL>
+                    <a:lnR w="0">
+                      <a:noFill/>
+                    </a:lnR>
+                    <a:lnT w="0">
+                      <a:noFill/>
+                    </a:lnT>
+                    <a:lnB w="0">
+                      <a:noFill/>
+                    </a:lnB>
+                  </a:tcPr>
+                </a:tc>
+                <a:tc>
+                  <a:txBody>
+                    <a:bodyPr/>
+                    <a:lstStyle/>
+                    <a:p>
+                      <a:r>
+                        <a:rPr sz="1300" b="0">
+                          <a:solidFill>
+                            <a:srgbClr val="FFFFFF"/>
+                          </a:solidFill>
+                          <a:latin typeface="Pretendard Medium"/>
+                        </a:rPr>
+                        <a:t>매번 승인</a:t>
+                      </a:r>
+                    </a:p>
+                  </a:txBody>
+                  <a:tcPr marL="101600" marR="101600" marT="76200" marB="76200" anchor="ctr">
+                    <a:solidFill>
+                      <a:srgbClr val="000000"/>
+                    </a:solidFill>
+                    <a:lnL w="0">
+                      <a:noFill/>
+                    </a:lnL>
+                    <a:lnR w="0">
+                      <a:noFill/>
+                    </a:lnR>
+                    <a:lnT w="0">
+                      <a:noFill/>
+                    </a:lnT>
+                    <a:lnB w="0">
+                      <a:noFill/>
+                    </a:lnB>
+                  </a:tcPr>
+                </a:tc>
+                <a:tc>
+                  <a:txBody>
+                    <a:bodyPr/>
+                    <a:lstStyle/>
+                    <a:p>
+                      <a:r>
+                        <a:rPr sz="1300" b="0">
+                          <a:solidFill>
+                            <a:srgbClr val="FFFFFF"/>
+                          </a:solidFill>
+                          <a:latin typeface="Pretendard Medium"/>
+                        </a:rPr>
+                        <a:t>부분 자동</a:t>
+                      </a:r>
+                    </a:p>
+                  </a:txBody>
+                  <a:tcPr marL="101600" marR="101600" marT="76200" marB="76200" anchor="ctr">
+                    <a:solidFill>
+                      <a:srgbClr val="000000"/>
+                    </a:solidFill>
+                    <a:lnL w="0">
+                      <a:noFill/>
+                    </a:lnL>
+                    <a:lnR w="0">
+                      <a:noFill/>
+                    </a:lnR>
+                    <a:lnT w="0">
+                      <a:noFill/>
+                    </a:lnT>
+                    <a:lnB w="0">
+                      <a:noFill/>
+                    </a:lnB>
+                  </a:tcPr>
+                </a:tc>
+                <a:tc>
+                  <a:txBody>
+                    <a:bodyPr/>
+                    <a:lstStyle/>
+                    <a:p>
+                      <a:r>
+                        <a:rPr sz="1300" b="0">
+                          <a:solidFill>
+                            <a:srgbClr val="FFFFFF"/>
+                          </a:solidFill>
+                          <a:latin typeface="Pretendard Medium"/>
+                        </a:rPr>
+                        <a:t>전면 자동</a:t>
+                      </a:r>
+                    </a:p>
+                  </a:txBody>
+                  <a:tcPr marL="101600" marR="101600" marT="76200" marB="76200" anchor="ctr">
+                    <a:solidFill>
+                      <a:srgbClr val="000000"/>
+                    </a:solidFill>
+                    <a:lnL w="0">
+                      <a:noFill/>
+                    </a:lnL>
+                    <a:lnR w="0">
+                      <a:noFill/>
+                    </a:lnR>
+                    <a:lnT w="0">
+                      <a:noFill/>
+                    </a:lnT>
+                    <a:lnB w="0">
+                      <a:noFill/>
+                    </a:lnB>
+                  </a:tcPr>
+                </a:tc>
+              </a:tr>
+              <a:tr h="635000">
+                <a:tc>
+                  <a:txBody>
+                    <a:bodyPr/>
+                    <a:lstStyle/>
+                    <a:p>
+                      <a:r>
+                        <a:rPr sz="1300" b="1">
+                          <a:solidFill>
+                            <a:srgbClr val="000000"/>
+                          </a:solidFill>
+                          <a:latin typeface="Pretendard"/>
+                        </a:rPr>
+                        <a:t>Claude Code</a:t>
+                      </a:r>
+                    </a:p>
+                  </a:txBody>
+                  <a:tcPr marL="101600" marR="101600" marT="101600" marB="101600" anchor="ctr">
+                    <a:solidFill>
+                      <a:srgbClr val="FFFFFF"/>
+                    </a:solidFill>
+                    <a:lnL w="0">
+                      <a:noFill/>
+                    </a:lnL>
+                    <a:lnR w="0">
+                      <a:noFill/>
+                    </a:lnR>
+                    <a:lnT w="0">
+                      <a:noFill/>
+                    </a:lnT>
+                    <a:lnB w="9525">
+                      <a:solidFill>
+                        <a:srgbClr val="E2E2E2"/>
+                      </a:solidFill>
+                    </a:lnB>
+                  </a:tcPr>
+                </a:tc>
+                <a:tc>
+                  <a:txBody>
+                    <a:bodyPr/>
+                    <a:lstStyle/>
+                    <a:p>
+                      <a:r>
+                        <a:rPr sz="1300" b="0">
+                          <a:solidFill>
+                            <a:srgbClr val="5E5E5E"/>
+                          </a:solidFill>
+                          <a:latin typeface="Pretendard Medium"/>
+                        </a:rPr>
+                        <a:t>기본 모드</a:t>
+                      </a:r>
+                    </a:p>
+                  </a:txBody>
+                  <a:tcPr marL="101600" marR="101600" marT="101600" marB="101600" anchor="ctr">
+                    <a:solidFill>
+                      <a:srgbClr val="FFFFFF"/>
+                    </a:solidFill>
+                    <a:lnL w="0">
+                      <a:noFill/>
+                    </a:lnL>
+                    <a:lnR w="0">
+                      <a:noFill/>
+                    </a:lnR>
+                    <a:lnT w="0">
+                      <a:noFill/>
+                    </a:lnT>
+                    <a:lnB w="9525">
+                      <a:solidFill>
+                        <a:srgbClr val="E2E2E2"/>
+                      </a:solidFill>
+                    </a:lnB>
+                  </a:tcPr>
+                </a:tc>
+                <a:tc>
+                  <a:txBody>
+                    <a:bodyPr/>
+                    <a:lstStyle/>
+                    <a:p>
+                      <a:r>
+                        <a:rPr sz="1300" b="0">
+                          <a:solidFill>
+                            <a:srgbClr val="5E5E5E"/>
+                          </a:solidFill>
+                          <a:latin typeface="Pretendard Medium"/>
+                        </a:rPr>
+                        <a:t>acceptEdits</a:t>
+                      </a:r>
+                    </a:p>
+                  </a:txBody>
+                  <a:tcPr marL="101600" marR="101600" marT="101600" marB="101600" anchor="ctr">
+                    <a:solidFill>
+                      <a:srgbClr val="FFFFFF"/>
+                    </a:solidFill>
+                    <a:lnL w="0">
+                      <a:noFill/>
+                    </a:lnL>
+                    <a:lnR w="0">
+                      <a:noFill/>
+                    </a:lnR>
+                    <a:lnT w="0">
+                      <a:noFill/>
+                    </a:lnT>
+                    <a:lnB w="9525">
+                      <a:solidFill>
+                        <a:srgbClr val="E2E2E2"/>
+                      </a:solidFill>
+                    </a:lnB>
+                  </a:tcPr>
+                </a:tc>
+                <a:tc>
+                  <a:txBody>
+                    <a:bodyPr/>
+                    <a:lstStyle/>
+                    <a:p>
+                      <a:r>
+                        <a:rPr sz="1300" b="0">
+                          <a:solidFill>
+                            <a:srgbClr val="5E5E5E"/>
+                          </a:solidFill>
+                          <a:latin typeface="Pretendard Medium"/>
+                        </a:rPr>
+                        <a:t>bypassPermissions</a:t>
+                      </a:r>
+                    </a:p>
+                  </a:txBody>
+                  <a:tcPr marL="101600" marR="101600" marT="101600" marB="101600" anchor="ctr">
+                    <a:solidFill>
+                      <a:srgbClr val="FFFFFF"/>
+                    </a:solidFill>
+                    <a:lnL w="0">
+                      <a:noFill/>
+                    </a:lnL>
+                    <a:lnR w="0">
+                      <a:noFill/>
+                    </a:lnR>
+                    <a:lnT w="0">
+                      <a:noFill/>
+                    </a:lnT>
+                    <a:lnB w="9525">
+                      <a:solidFill>
+                        <a:srgbClr val="E2E2E2"/>
+                      </a:solidFill>
+                    </a:lnB>
+                  </a:tcPr>
+                </a:tc>
+              </a:tr>
+              <a:tr h="635000">
+                <a:tc>
+                  <a:txBody>
+                    <a:bodyPr/>
+                    <a:lstStyle/>
+                    <a:p>
+                      <a:r>
+                        <a:rPr sz="1300" b="1">
+                          <a:solidFill>
+                            <a:srgbClr val="000000"/>
+                          </a:solidFill>
+                          <a:latin typeface="Pretendard"/>
+                        </a:rPr>
+                        <a:t>Codex</a:t>
+                      </a:r>
+                    </a:p>
+                  </a:txBody>
+                  <a:tcPr marL="101600" marR="101600" marT="101600" marB="101600" anchor="ctr">
+                    <a:solidFill>
+                      <a:srgbClr val="FFFFFF"/>
+                    </a:solidFill>
+                    <a:lnL w="0">
+                      <a:noFill/>
+                    </a:lnL>
+                    <a:lnR w="0">
+                      <a:noFill/>
+                    </a:lnR>
+                    <a:lnT w="0">
+                      <a:noFill/>
+                    </a:lnT>
+                    <a:lnB w="9525">
+                      <a:solidFill>
+                        <a:srgbClr val="E2E2E2"/>
+                      </a:solidFill>
+                    </a:lnB>
+                  </a:tcPr>
+                </a:tc>
+                <a:tc>
+                  <a:txBody>
+                    <a:bodyPr/>
+                    <a:lstStyle/>
+                    <a:p>
+                      <a:r>
+                        <a:rPr sz="1300" b="0">
+                          <a:solidFill>
+                            <a:srgbClr val="5E5E5E"/>
+                          </a:solidFill>
+                          <a:latin typeface="Pretendard Medium"/>
+                        </a:rPr>
+                        <a:t>ask-for-approval</a:t>
+                      </a:r>
+                    </a:p>
+                  </a:txBody>
+                  <a:tcPr marL="101600" marR="101600" marT="101600" marB="101600" anchor="ctr">
+                    <a:solidFill>
+                      <a:srgbClr val="FFFFFF"/>
+                    </a:solidFill>
+                    <a:lnL w="0">
+                      <a:noFill/>
+                    </a:lnL>
+                    <a:lnR w="0">
+                      <a:noFill/>
+                    </a:lnR>
+                    <a:lnT w="0">
+                      <a:noFill/>
+                    </a:lnT>
+                    <a:lnB w="9525">
+                      <a:solidFill>
+                        <a:srgbClr val="E2E2E2"/>
+                      </a:solidFill>
+                    </a:lnB>
+                  </a:tcPr>
+                </a:tc>
+                <a:tc>
+                  <a:txBody>
+                    <a:bodyPr/>
+                    <a:lstStyle/>
+                    <a:p>
+                      <a:r>
+                        <a:rPr sz="1300" b="0">
+                          <a:solidFill>
+                            <a:srgbClr val="5E5E5E"/>
+                          </a:solidFill>
+                          <a:latin typeface="Pretendard Medium"/>
+                        </a:rPr>
+                        <a:t>full-auto</a:t>
+                      </a:r>
+                    </a:p>
+                  </a:txBody>
+                  <a:tcPr marL="101600" marR="101600" marT="101600" marB="101600" anchor="ctr">
+                    <a:solidFill>
+                      <a:srgbClr val="FFFFFF"/>
+                    </a:solidFill>
+                    <a:lnL w="0">
+                      <a:noFill/>
+                    </a:lnL>
+                    <a:lnR w="0">
+                      <a:noFill/>
+                    </a:lnR>
+                    <a:lnT w="0">
+                      <a:noFill/>
+                    </a:lnT>
+                    <a:lnB w="9525">
+                      <a:solidFill>
+                        <a:srgbClr val="E2E2E2"/>
+                      </a:solidFill>
+                    </a:lnB>
+                  </a:tcPr>
+                </a:tc>
+                <a:tc>
+                  <a:txBody>
+                    <a:bodyPr/>
+                    <a:lstStyle/>
+                    <a:p>
+                      <a:r>
+                        <a:rPr sz="1300" b="0">
+                          <a:solidFill>
+                            <a:srgbClr val="5E5E5E"/>
+                          </a:solidFill>
+                          <a:latin typeface="Pretendard Medium"/>
+                        </a:rPr>
+                        <a:t>yolo</a:t>
+                      </a:r>
+                    </a:p>
+                  </a:txBody>
+                  <a:tcPr marL="101600" marR="101600" marT="101600" marB="101600" anchor="ctr">
+                    <a:solidFill>
+                      <a:srgbClr val="FFFFFF"/>
+                    </a:solidFill>
+                    <a:lnL w="0">
+                      <a:noFill/>
+                    </a:lnL>
+                    <a:lnR w="0">
+                      <a:noFill/>
+                    </a:lnR>
+                    <a:lnT w="0">
+                      <a:noFill/>
+                    </a:lnT>
+                    <a:lnB w="9525">
+                      <a:solidFill>
+                        <a:srgbClr val="E2E2E2"/>
+                      </a:solidFill>
+                    </a:lnB>
+                  </a:tcPr>
+                </a:tc>
+              </a:tr>
+              <a:tr h="635000">
+                <a:tc>
+                  <a:txBody>
+                    <a:bodyPr/>
+                    <a:lstStyle/>
+                    <a:p>
+                      <a:r>
+                        <a:rPr sz="1300" b="1">
+                          <a:solidFill>
+                            <a:srgbClr val="000000"/>
+                          </a:solidFill>
+                          <a:latin typeface="Pretendard"/>
+                        </a:rPr>
+                        <a:t>Antigravity 편집기</a:t>
+                      </a:r>
+                    </a:p>
+                  </a:txBody>
+                  <a:tcPr marL="101600" marR="101600" marT="101600" marB="101600" anchor="ctr">
+                    <a:solidFill>
+                      <a:srgbClr val="FFFFFF"/>
+                    </a:solidFill>
+                    <a:lnL w="0">
+                      <a:noFill/>
+                    </a:lnL>
+                    <a:lnR w="0">
+                      <a:noFill/>
+                    </a:lnR>
+                    <a:lnT w="0">
+                      <a:noFill/>
+                    </a:lnT>
+                    <a:lnB w="9525">
+                      <a:solidFill>
+                        <a:srgbClr val="E2E2E2"/>
+                      </a:solidFill>
+                    </a:lnB>
+                  </a:tcPr>
+                </a:tc>
+                <a:tc>
+                  <a:txBody>
+                    <a:bodyPr/>
+                    <a:lstStyle/>
+                    <a:p>
+                      <a:r>
+                        <a:rPr sz="1300" b="0">
+                          <a:solidFill>
+                            <a:srgbClr val="5E5E5E"/>
+                          </a:solidFill>
+                          <a:latin typeface="Pretendard Medium"/>
+                        </a:rPr>
+                        <a:t>Request Review</a:t>
+                      </a:r>
+                    </a:p>
+                  </a:txBody>
+                  <a:tcPr marL="101600" marR="101600" marT="101600" marB="101600" anchor="ctr">
+                    <a:solidFill>
+                      <a:srgbClr val="FFFFFF"/>
+                    </a:solidFill>
+                    <a:lnL w="0">
+                      <a:noFill/>
+                    </a:lnL>
+                    <a:lnR w="0">
+                      <a:noFill/>
+                    </a:lnR>
+                    <a:lnT w="0">
+                      <a:noFill/>
+                    </a:lnT>
+                    <a:lnB w="9525">
+                      <a:solidFill>
+                        <a:srgbClr val="E2E2E2"/>
+                      </a:solidFill>
+                    </a:lnB>
+                  </a:tcPr>
+                </a:tc>
+                <a:tc>
+                  <a:txBody>
+                    <a:bodyPr/>
+                    <a:lstStyle/>
+                    <a:p>
+                      <a:r>
+                        <a:rPr sz="1300" b="0">
+                          <a:solidFill>
+                            <a:srgbClr val="5E5E5E"/>
+                          </a:solidFill>
+                          <a:latin typeface="Pretendard Medium"/>
+                        </a:rPr>
+                        <a:t>Proceed in Sandbox</a:t>
+                      </a:r>
+                    </a:p>
+                  </a:txBody>
+                  <a:tcPr marL="101600" marR="101600" marT="101600" marB="101600" anchor="ctr">
+                    <a:solidFill>
+                      <a:srgbClr val="FFFFFF"/>
+                    </a:solidFill>
+                    <a:lnL w="0">
+                      <a:noFill/>
+                    </a:lnL>
+                    <a:lnR w="0">
+                      <a:noFill/>
+                    </a:lnR>
+                    <a:lnT w="0">
+                      <a:noFill/>
+                    </a:lnT>
+                    <a:lnB w="9525">
+                      <a:solidFill>
+                        <a:srgbClr val="E2E2E2"/>
+                      </a:solidFill>
+                    </a:lnB>
+                  </a:tcPr>
+                </a:tc>
+                <a:tc>
+                  <a:txBody>
+                    <a:bodyPr/>
+                    <a:lstStyle/>
+                    <a:p>
+                      <a:r>
+                        <a:rPr sz="1300" b="0">
+                          <a:solidFill>
+                            <a:srgbClr val="5E5E5E"/>
+                          </a:solidFill>
+                          <a:latin typeface="Pretendard Medium"/>
+                        </a:rPr>
+                        <a:t>Always Proceed</a:t>
+                      </a:r>
+                    </a:p>
+                  </a:txBody>
+                  <a:tcPr marL="101600" marR="101600" marT="101600" marB="101600" anchor="ctr">
+                    <a:solidFill>
+                      <a:srgbClr val="FFFFFF"/>
+                    </a:solidFill>
+                    <a:lnL w="0">
+                      <a:noFill/>
+                    </a:lnL>
+                    <a:lnR w="0">
+                      <a:noFill/>
+                    </a:lnR>
+                    <a:lnT w="0">
+                      <a:noFill/>
+                    </a:lnT>
+                    <a:lnB w="9525">
+                      <a:solidFill>
+                        <a:srgbClr val="E2E2E2"/>
+                      </a:solidFill>
+                    </a:lnB>
+                  </a:tcPr>
+                </a:tc>
+              </a:tr>
+              <a:tr h="635000">
+                <a:tc>
+                  <a:txBody>
+                    <a:bodyPr/>
+                    <a:lstStyle/>
+                    <a:p>
+                      <a:r>
+                        <a:rPr sz="1300" b="1">
+                          <a:solidFill>
+                            <a:srgbClr val="000000"/>
+                          </a:solidFill>
+                          <a:latin typeface="Pretendard"/>
+                        </a:rPr>
+                        <a:t>Antigravity CLI</a:t>
+                      </a:r>
+                    </a:p>
+                  </a:txBody>
+                  <a:tcPr marL="101600" marR="101600" marT="101600" marB="101600" anchor="ctr">
+                    <a:solidFill>
+                      <a:srgbClr val="FFFFFF"/>
+                    </a:solidFill>
+                    <a:lnL w="0">
+                      <a:noFill/>
+                    </a:lnL>
+                    <a:lnR w="0">
+                      <a:noFill/>
+                    </a:lnR>
+                    <a:lnT w="0">
+                      <a:noFill/>
+                    </a:lnT>
+                    <a:lnB w="9525">
+                      <a:solidFill>
+                        <a:srgbClr val="E2E2E2"/>
+                      </a:solidFill>
+                    </a:lnB>
+                  </a:tcPr>
+                </a:tc>
+                <a:tc>
+                  <a:txBody>
+                    <a:bodyPr/>
+                    <a:lstStyle/>
+                    <a:p>
+                      <a:r>
+                        <a:rPr sz="1300" b="0">
+                          <a:solidFill>
+                            <a:srgbClr val="5E5E5E"/>
+                          </a:solidFill>
+                          <a:latin typeface="Pretendard Medium"/>
+                        </a:rPr>
+                        <a:t>기본 모드</a:t>
+                      </a:r>
+                    </a:p>
+                  </a:txBody>
+                  <a:tcPr marL="101600" marR="101600" marT="101600" marB="101600" anchor="ctr">
+                    <a:solidFill>
+                      <a:srgbClr val="FFFFFF"/>
+                    </a:solidFill>
+                    <a:lnL w="0">
+                      <a:noFill/>
+                    </a:lnL>
+                    <a:lnR w="0">
+                      <a:noFill/>
+                    </a:lnR>
+                    <a:lnT w="0">
+                      <a:noFill/>
+                    </a:lnT>
+                    <a:lnB w="9525">
+                      <a:solidFill>
+                        <a:srgbClr val="E2E2E2"/>
+                      </a:solidFill>
+                    </a:lnB>
+                  </a:tcPr>
+                </a:tc>
+                <a:tc>
+                  <a:txBody>
+                    <a:bodyPr/>
+                    <a:lstStyle/>
+                    <a:p>
+                      <a:r>
+                        <a:rPr sz="1300" b="0">
+                          <a:solidFill>
+                            <a:srgbClr val="5E5E5E"/>
+                          </a:solidFill>
+                          <a:latin typeface="Pretendard Medium"/>
+                        </a:rPr>
+                        <a:t>/permissions에서 지정</a:t>
+                      </a:r>
+                    </a:p>
+                  </a:txBody>
+                  <a:tcPr marL="101600" marR="101600" marT="101600" marB="101600" anchor="ctr">
+                    <a:solidFill>
+                      <a:srgbClr val="FFFFFF"/>
+                    </a:solidFill>
+                    <a:lnL w="0">
+                      <a:noFill/>
+                    </a:lnL>
+                    <a:lnR w="0">
+                      <a:noFill/>
+                    </a:lnR>
+                    <a:lnT w="0">
+                      <a:noFill/>
+                    </a:lnT>
+                    <a:lnB w="9525">
+                      <a:solidFill>
+                        <a:srgbClr val="E2E2E2"/>
+                      </a:solidFill>
+                    </a:lnB>
+                  </a:tcPr>
+                </a:tc>
+                <a:tc>
+                  <a:txBody>
+                    <a:bodyPr/>
+                    <a:lstStyle/>
+                    <a:p>
+                      <a:r>
+                        <a:rPr sz="1300" b="0">
+                          <a:solidFill>
+                            <a:srgbClr val="5E5E5E"/>
+                          </a:solidFill>
+                          <a:latin typeface="Pretendard Medium"/>
+                        </a:rPr>
+                        <a:t>시작 옵션으로 지정</a:t>
+                      </a:r>
+                    </a:p>
+                  </a:txBody>
+                  <a:tcPr marL="101600" marR="101600" marT="101600" marB="101600" anchor="ctr">
+                    <a:solidFill>
+                      <a:srgbClr val="FFFFFF"/>
+                    </a:solidFill>
+                    <a:lnL w="0">
+                      <a:noFill/>
+                    </a:lnL>
+                    <a:lnR w="0">
+                      <a:noFill/>
+                    </a:lnR>
+                    <a:lnT w="0">
+                      <a:noFill/>
+                    </a:lnT>
+                    <a:lnB w="9525">
+                      <a:solidFill>
+                        <a:srgbClr val="E2E2E2"/>
+                      </a:solidFill>
+                    </a:lnB>
+                  </a:tcPr>
+                </a:tc>
+              </a:tr>
+            </a:tbl>
+          </a:graphicData>
+        </a:graphic>
+      </p:graphicFrame>
       <p:sp>
         <p:nvSpPr>
           <p:cNvPr id="25" name="Slide Number Placeholder 0"/>
@@ -9718,7 +9894,7 @@
             <a:pPr algn="r"/>
             <a:fld id="{F7021451-1387-4CA6-816F-3879F97B5CBC}" type="slidenum">
               <a:rPr b="0" lang="en-US"/>
-              <a:t>1004</a:t>
+              <a:t>1008</a:t>
             </a:fld>
             <a:endParaRPr lang="en-US"/>
           </a:p>
@@ -9758,7 +9934,7 @@
           <a:lstStyle/>
           <a:p>
             <a:r>
-              <a:t>4.4 첫 지시 문장</a:t>
+              <a:t>4.3 Git 커밋과 복구</a:t>
             </a:r>
           </a:p>
         </p:txBody>
@@ -9801,25 +9977,25 @@
           <a:p>
             <a:pPr/>
             <a:r>
-              <a:t>지시 예시: requirements.txt로 가상환경 생성과 설치 · 실패 시 오류 원문과 원인 보고</a:t>
+              <a:t>Git: 폴더 안의 파일이 언제 어떻게 바뀌었는지 이력으로 저장하는 도구</a:t>
             </a:r>
           </a:p>
           <a:p>
             <a:pPr/>
             <a:r>
-              <a:t>오류 전달 방식: 화면 캡처 대신 터미널 출력 원문</a:t>
+              <a:t>커밋: 그 시점의 파일 상태를 이력에 기록 — 되돌아갈 지점</a:t>
             </a:r>
           </a:p>
           <a:p>
             <a:pPr/>
             <a:r>
-              <a:t>작업 단위: 설치와 분석을 한 지시에 섞지 않고 하나씩 요청</a:t>
+              <a:t>되돌리기: git restore로 마지막 커밋 상태로 복구</a:t>
             </a:r>
           </a:p>
           <a:p>
             <a:pPr/>
             <a:r>
-              <a:t>실행 전 확인: 수정할 파일과 실행할 명령을 먼저 설명하도록 요청</a:t>
+              <a:t>변경 확인: git diff로 커밋 이후 바뀐 부분만 표시</a:t>
             </a:r>
           </a:p>
         </p:txBody>
@@ -9906,7 +10082,7 @@
           <a:lstStyle/>
           <a:p>
             <a:r>
-              <a:t>4.5 에이전트가 판단할 수 없는 것</a:t>
+              <a:t>4.4 전면 자동을 쓰는 조건</a:t>
             </a:r>
           </a:p>
         </p:txBody>
@@ -9949,25 +10125,25 @@
           <a:p>
             <a:pPr/>
             <a:r>
-              <a:t>데이터의 의미와 결과의 타당성 판단</a:t>
+              <a:t>커밋된 Git 저장소: 잘못 고친 파일을 직전 커밋으로 되돌릴 수 있음</a:t>
             </a:r>
           </a:p>
           <a:p>
             <a:pPr/>
             <a:r>
-              <a:t>과목 규칙 — 제출 형식, 마감, 허용 범위</a:t>
+              <a:t>과제나 실습 폴더: 개인 자료와 자격증명이 없어 잘못 열려도 피해 없음</a:t>
             </a:r>
           </a:p>
           <a:p>
             <a:pPr/>
             <a:r>
-              <a:t>실제 변경 사항의 최종 확인: git status와 파일 목록</a:t>
+              <a:t>결과 확인 방법이 정해진 상태: 승인을 건너뛴 만큼 사후 확인이 필요</a:t>
             </a:r>
           </a:p>
           <a:p>
             <a:pPr/>
             <a:r>
-              <a:t>제출물의 정확성에 대한 책임: 제출한 학생</a:t>
+              <a:t>제외 대상: 홈 폴더, 연구실 공용 저장소, 자격증명이 있는 폴더</a:t>
             </a:r>
           </a:p>
         </p:txBody>
@@ -10040,42 +10216,42 @@
       <p:grpSpPr/>
       <p:sp>
         <p:nvSpPr>
-          <p:cNvPr id="2" name="Text Placeholder 1"/>
-          <p:cNvSpPr>
-            <a:spLocks noGrp="1"/>
-          </p:cNvSpPr>
-          <p:nvPr>
-            <p:ph type="body" idx="100"/>
-          </p:nvPr>
-        </p:nvSpPr>
-        <p:spPr/>
-        <p:txBody>
-          <a:bodyPr/>
-          <a:lstStyle/>
-          <a:p>
-            <a:r>
-              <a:t>05</a:t>
-            </a:r>
-          </a:p>
-        </p:txBody>
-      </p:sp>
-      <p:sp>
-        <p:nvSpPr>
-          <p:cNvPr id="3" name="Title 2"/>
-          <p:cNvSpPr>
-            <a:spLocks noGrp="1"/>
-          </p:cNvSpPr>
-          <p:nvPr>
-            <p:ph type="title" idx="101"/>
-          </p:nvPr>
-        </p:nvSpPr>
-        <p:spPr/>
-        <p:txBody>
-          <a:bodyPr/>
-          <a:lstStyle/>
-          <a:p>
-            <a:r>
-              <a:t>확인과 기록</a:t>
+          <p:cNvPr id="2" name="Title 1"/>
+          <p:cNvSpPr>
+            <a:spLocks noGrp="1"/>
+          </p:cNvSpPr>
+          <p:nvPr>
+            <p:ph type="title" idx="100"/>
+          </p:nvPr>
+        </p:nvSpPr>
+        <p:spPr/>
+        <p:txBody>
+          <a:bodyPr/>
+          <a:lstStyle/>
+          <a:p>
+            <a:r>
+              <a:t>4.5 에이전트가 판단할 수 없는 것</a:t>
+            </a:r>
+          </a:p>
+        </p:txBody>
+      </p:sp>
+      <p:sp>
+        <p:nvSpPr>
+          <p:cNvPr id="3" name="Text Placeholder 2"/>
+          <p:cNvSpPr>
+            <a:spLocks noGrp="1"/>
+          </p:cNvSpPr>
+          <p:nvPr>
+            <p:ph type="body" idx="101"/>
+          </p:nvPr>
+        </p:nvSpPr>
+        <p:spPr/>
+        <p:txBody>
+          <a:bodyPr/>
+          <a:lstStyle/>
+          <a:p>
+            <a:r>
+              <a:t>4. 에이전트 실행과 권한</a:t>
             </a:r>
           </a:p>
         </p:txBody>
@@ -10095,94 +10271,76 @@
           <a:bodyPr/>
           <a:lstStyle/>
           <a:p>
-            <a:pPr>
-              <a:spcAft>
-                <a:spcPts val="1000"/>
-              </a:spcAft>
-            </a:pPr>
-            <a:r>
-              <a:rPr>
+            <a:pPr/>
+            <a:r>
+              <a:t>데이터의 의미와 결과의 타당성 판단</a:t>
+            </a:r>
+          </a:p>
+          <a:p>
+            <a:pPr/>
+            <a:r>
+              <a:t>과목 규칙 — 제출 형식, 마감, 허용 범위</a:t>
+            </a:r>
+          </a:p>
+          <a:p>
+            <a:pPr/>
+            <a:r>
+              <a:t>실제 변경 사항의 최종 확인: git status와 파일 목록</a:t>
+            </a:r>
+          </a:p>
+          <a:p>
+            <a:pPr/>
+            <a:r>
+              <a:t>제출물의 정확성에 대한 책임: 제출한 학생</a:t>
+            </a:r>
+          </a:p>
+        </p:txBody>
+      </p:sp>
+      <p:sp>
+        <p:nvSpPr>
+          <p:cNvPr id="25" name="Slide Number Placeholder 0"/>
+          <p:cNvSpPr>
+            <a:spLocks noGrp="1"/>
+          </p:cNvSpPr>
+          <p:nvPr>
+            <p:ph type="sldNum" sz="quarter" idx="4294967295"/>
+          </p:nvPr>
+        </p:nvSpPr>
+        <p:spPr>
+          <a:xfrm>
+            <a:off x="10591495" y="6355080"/>
+            <a:ext cx="914400" cy="274320"/>
+          </a:xfrm>
+          <a:prstGeom prst="rect">
+            <a:avLst/>
+          </a:prstGeom>
+          <a:extLst>
+            <a:ext uri="{C572A759-6A51-4108-AA02-DFA0A04FC94B}">
+              <ma14:wrappingTextBoxFlag xmlns:ma14="http://schemas.microsoft.com/office/mac/drawingml/2011/main" val="0"/>
+            </a:ext>
+          </a:extLst>
+        </p:spPr>
+        <p:txBody>
+          <a:bodyPr/>
+          <a:lstStyle>
+            <a:lvl1pPr>
+              <a:defRPr sz="1000">
                 <a:solidFill>
                   <a:srgbClr val="AFAFAF"/>
                 </a:solidFill>
-              </a:rPr>
-              <a:t>5.1  </a:t>
-            </a:r>
-            <a:r>
-              <a:t>결과 확인 항목</a:t>
-            </a:r>
-          </a:p>
-          <a:p>
-            <a:pPr>
-              <a:spcAft>
-                <a:spcPts val="1000"/>
-              </a:spcAft>
-            </a:pPr>
-            <a:r>
-              <a:rPr>
-                <a:solidFill>
-                  <a:srgbClr val="AFAFAF"/>
-                </a:solidFill>
-              </a:rPr>
-              <a:t>5.2  </a:t>
-            </a:r>
-            <a:r>
-              <a:t>자주 쓰는 명령</a:t>
-            </a:r>
-          </a:p>
-          <a:p>
-            <a:pPr>
-              <a:spcAft>
-                <a:spcPts val="1000"/>
-              </a:spcAft>
-            </a:pPr>
-            <a:r>
-              <a:rPr>
-                <a:solidFill>
-                  <a:srgbClr val="AFAFAF"/>
-                </a:solidFill>
-              </a:rPr>
-              <a:t>5.3  </a:t>
-            </a:r>
-            <a:r>
-              <a:t>대화를 비우는 기준</a:t>
-            </a:r>
-          </a:p>
-          <a:p>
-            <a:pPr>
-              <a:spcAft>
-                <a:spcPts val="1000"/>
-              </a:spcAft>
-            </a:pPr>
-            <a:r>
-              <a:rPr>
-                <a:solidFill>
-                  <a:srgbClr val="AFAFAF"/>
-                </a:solidFill>
-              </a:rPr>
-              <a:t>5.4  </a:t>
-            </a:r>
-            <a:r>
-              <a:t>모델 선택</a:t>
-            </a:r>
-          </a:p>
-          <a:p>
-            <a:pPr>
-              <a:spcAft>
-                <a:spcPts val="1000"/>
-              </a:spcAft>
-            </a:pPr>
-            <a:r>
-              <a:rPr>
-                <a:solidFill>
-                  <a:srgbClr val="AFAFAF"/>
-                </a:solidFill>
-              </a:rPr>
-              <a:t>5.5  </a:t>
-            </a:r>
-            <a:r>
-              <a:t>md 파일로 남기는 맥락</a:t>
-            </a:r>
+                <a:latin typeface="Pretendard Medium"/>
+                <a:ea typeface="Pretendard Medium"/>
+                <a:cs typeface="Pretendard Medium"/>
+              </a:defRPr>
+            </a:lvl1pPr>
+          </a:lstStyle>
+          <a:p>
+            <a:pPr algn="r"/>
+            <a:fld id="{F7021451-1387-4CA6-816F-3879F97B5CBC}" type="slidenum">
+              <a:rPr b="0" lang="en-US"/>
+              <a:t>1004</a:t>
+            </a:fld>
+            <a:endParaRPr lang="en-US"/>
           </a:p>
         </p:txBody>
       </p:sp>
@@ -10206,42 +10364,42 @@
       <p:grpSpPr/>
       <p:sp>
         <p:nvSpPr>
-          <p:cNvPr id="2" name="Title 1"/>
-          <p:cNvSpPr>
-            <a:spLocks noGrp="1"/>
-          </p:cNvSpPr>
-          <p:nvPr>
-            <p:ph type="title" idx="100"/>
-          </p:nvPr>
-        </p:nvSpPr>
-        <p:spPr/>
-        <p:txBody>
-          <a:bodyPr/>
-          <a:lstStyle/>
-          <a:p>
-            <a:r>
-              <a:t>5.1 결과 확인 항목</a:t>
-            </a:r>
-          </a:p>
-        </p:txBody>
-      </p:sp>
-      <p:sp>
-        <p:nvSpPr>
-          <p:cNvPr id="3" name="Text Placeholder 2"/>
-          <p:cNvSpPr>
-            <a:spLocks noGrp="1"/>
-          </p:cNvSpPr>
-          <p:nvPr>
-            <p:ph type="body" idx="101"/>
-          </p:nvPr>
-        </p:nvSpPr>
-        <p:spPr/>
-        <p:txBody>
-          <a:bodyPr/>
-          <a:lstStyle/>
-          <a:p>
-            <a:r>
-              <a:t>5. 확인과 기록</a:t>
+          <p:cNvPr id="2" name="Text Placeholder 1"/>
+          <p:cNvSpPr>
+            <a:spLocks noGrp="1"/>
+          </p:cNvSpPr>
+          <p:nvPr>
+            <p:ph type="body" idx="100"/>
+          </p:nvPr>
+        </p:nvSpPr>
+        <p:spPr/>
+        <p:txBody>
+          <a:bodyPr/>
+          <a:lstStyle/>
+          <a:p>
+            <a:r>
+              <a:t>05</a:t>
+            </a:r>
+          </a:p>
+        </p:txBody>
+      </p:sp>
+      <p:sp>
+        <p:nvSpPr>
+          <p:cNvPr id="3" name="Title 2"/>
+          <p:cNvSpPr>
+            <a:spLocks noGrp="1"/>
+          </p:cNvSpPr>
+          <p:nvPr>
+            <p:ph type="title" idx="101"/>
+          </p:nvPr>
+        </p:nvSpPr>
+        <p:spPr/>
+        <p:txBody>
+          <a:bodyPr/>
+          <a:lstStyle/>
+          <a:p>
+            <a:r>
+              <a:t>명령과 기록</a:t>
             </a:r>
           </a:p>
         </p:txBody>
@@ -10261,76 +10419,76 @@
           <a:bodyPr/>
           <a:lstStyle/>
           <a:p>
-            <a:pPr/>
-            <a:r>
-              <a:t>행 수: 읽어들인 결과가 원본 파일과 일치</a:t>
-            </a:r>
-          </a:p>
-          <a:p>
-            <a:pPr/>
-            <a:r>
-              <a:t>결측: 삭제인지 대체인지, 대체면 어떤 값인지</a:t>
-            </a:r>
-          </a:p>
-          <a:p>
-            <a:pPr/>
-            <a:r>
-              <a:t>필터: 조건이 의도한 범위와 일치</a:t>
-            </a:r>
-          </a:p>
-          <a:p>
-            <a:pPr/>
-            <a:r>
-              <a:t>검증하지 않은 코드: 이후 오차의 원인이 될 가능성</a:t>
-            </a:r>
-          </a:p>
-        </p:txBody>
-      </p:sp>
-      <p:sp>
-        <p:nvSpPr>
-          <p:cNvPr id="25" name="Slide Number Placeholder 0"/>
-          <p:cNvSpPr>
-            <a:spLocks noGrp="1"/>
-          </p:cNvSpPr>
-          <p:nvPr>
-            <p:ph type="sldNum" sz="quarter" idx="4294967295"/>
-          </p:nvPr>
-        </p:nvSpPr>
-        <p:spPr>
-          <a:xfrm>
-            <a:off x="10591495" y="6355080"/>
-            <a:ext cx="914400" cy="274320"/>
-          </a:xfrm>
-          <a:prstGeom prst="rect">
-            <a:avLst/>
-          </a:prstGeom>
-          <a:extLst>
-            <a:ext uri="{C572A759-6A51-4108-AA02-DFA0A04FC94B}">
-              <ma14:wrappingTextBoxFlag xmlns:ma14="http://schemas.microsoft.com/office/mac/drawingml/2011/main" val="0"/>
-            </a:ext>
-          </a:extLst>
-        </p:spPr>
-        <p:txBody>
-          <a:bodyPr/>
-          <a:lstStyle>
-            <a:lvl1pPr>
-              <a:defRPr sz="1000">
+            <a:pPr>
+              <a:spcAft>
+                <a:spcPts val="1000"/>
+              </a:spcAft>
+            </a:pPr>
+            <a:r>
+              <a:rPr>
                 <a:solidFill>
                   <a:srgbClr val="AFAFAF"/>
                 </a:solidFill>
-                <a:latin typeface="Pretendard Medium"/>
-                <a:ea typeface="Pretendard Medium"/>
-                <a:cs typeface="Pretendard Medium"/>
-              </a:defRPr>
-            </a:lvl1pPr>
-          </a:lstStyle>
-          <a:p>
-            <a:pPr algn="r"/>
-            <a:fld id="{F7021451-1387-4CA6-816F-3879F97B5CBC}" type="slidenum">
-              <a:rPr b="0" lang="en-US"/>
-              <a:t>1004</a:t>
-            </a:fld>
-            <a:endParaRPr lang="en-US"/>
+              </a:rPr>
+              <a:t>5.1  </a:t>
+            </a:r>
+            <a:r>
+              <a:t>자주 쓰는 명령</a:t>
+            </a:r>
+          </a:p>
+          <a:p>
+            <a:pPr>
+              <a:spcAft>
+                <a:spcPts val="1000"/>
+              </a:spcAft>
+            </a:pPr>
+            <a:r>
+              <a:rPr>
+                <a:solidFill>
+                  <a:srgbClr val="AFAFAF"/>
+                </a:solidFill>
+              </a:rPr>
+              <a:t>5.2  </a:t>
+            </a:r>
+            <a:r>
+              <a:t>대화를 비우는 기준</a:t>
+            </a:r>
+          </a:p>
+          <a:p>
+            <a:pPr>
+              <a:spcAft>
+                <a:spcPts val="1000"/>
+              </a:spcAft>
+            </a:pPr>
+            <a:r>
+              <a:rPr>
+                <a:solidFill>
+                  <a:srgbClr val="AFAFAF"/>
+                </a:solidFill>
+              </a:rPr>
+              <a:t>5.3  </a:t>
+            </a:r>
+            <a:r>
+              <a:t>모델 선택</a:t>
+            </a:r>
+          </a:p>
+          <a:p>
+            <a:pPr>
+              <a:spcAft>
+                <a:spcPts val="1000"/>
+              </a:spcAft>
+            </a:pPr>
+            <a:r>
+              <a:rPr>
+                <a:solidFill>
+                  <a:srgbClr val="AFAFAF"/>
+                </a:solidFill>
+              </a:rPr>
+              <a:t>5.4  </a:t>
+            </a:r>
+            <a:r>
+              <a:t>md 파일로 남기는 맥락</a:t>
+            </a:r>
           </a:p>
         </p:txBody>
       </p:sp>
@@ -10368,7 +10526,7 @@
           <a:lstStyle/>
           <a:p>
             <a:r>
-              <a:t>5.2 자주 쓰는 명령</a:t>
+              <a:t>5.1 자주 쓰는 명령</a:t>
             </a:r>
           </a:p>
         </p:txBody>
@@ -10389,7 +10547,7 @@
           <a:lstStyle/>
           <a:p>
             <a:r>
-              <a:t>5. 확인과 기록</a:t>
+              <a:t>5. 명령과 기록</a:t>
             </a:r>
           </a:p>
         </p:txBody>
@@ -10411,19 +10569,19 @@
           <a:p>
             <a:pPr/>
             <a:r>
-              <a:t>사용량 확인: Claude Code는 /context와 /usage · Codex는 /status</a:t>
+              <a:t>사용량 확인: Claude Code와 Antigravity는 /context와 /usage · Codex는 /status</a:t>
             </a:r>
           </a:p>
           <a:p>
             <a:pPr/>
             <a:r>
-              <a:t>변경 취소: Claude Code는 /rewind · 공통으로 git diff와 git restore</a:t>
+              <a:t>변경 취소: Claude Code와 Antigravity는 /rewind · 공통으로 git diff와 git restore</a:t>
             </a:r>
           </a:p>
           <a:p>
             <a:pPr/>
             <a:r>
-              <a:t>이전 작업 이어가기: claude --continue 또는 claude --resume</a:t>
+              <a:t>이전 작업 이어가기: claude --continue · agy는 /resume</a:t>
             </a:r>
           </a:p>
         </p:txBody>
@@ -10468,9 +10626,10 @@
             <a:tbl>
               <a:tblPr firstRow="0" bandRow="0" firstCol="0" lastRow="0" lastCol="0" bandCol="0"/>
               <a:tblGrid>
-                <a:gridCol w="2188464"/>
-                <a:gridCol w="2188464"/>
-                <a:gridCol w="2188464"/>
+                <a:gridCol w="1641348"/>
+                <a:gridCol w="1641348"/>
+                <a:gridCol w="1641348"/>
+                <a:gridCol w="1641348"/>
               </a:tblGrid>
               <a:tr h="406400">
                 <a:tc>
@@ -10575,6 +10734,40 @@
                     </a:lnB>
                   </a:tcPr>
                 </a:tc>
+                <a:tc>
+                  <a:txBody>
+                    <a:bodyPr/>
+                    <a:lstStyle/>
+                    <a:p>
+                      <a:r>
+                        <a:rPr sz="1300" b="0">
+                          <a:solidFill>
+                            <a:srgbClr val="FFFFFF"/>
+                          </a:solidFill>
+                          <a:latin typeface="Pretendard Medium"/>
+                        </a:rPr>
+                        <a:t>Antigravity</a:t>
+                      </a:r>
+                    </a:p>
+                  </a:txBody>
+                  <a:tcPr marL="101600" marR="101600" marT="76200" marB="76200" anchor="ctr">
+                    <a:solidFill>
+                      <a:srgbClr val="000000"/>
+                    </a:solidFill>
+                    <a:lnL w="0">
+                      <a:noFill/>
+                    </a:lnL>
+                    <a:lnR w="0">
+                      <a:noFill/>
+                    </a:lnR>
+                    <a:lnT w="0">
+                      <a:noFill/>
+                    </a:lnT>
+                    <a:lnB w="0">
+                      <a:noFill/>
+                    </a:lnB>
+                  </a:tcPr>
+                </a:tc>
               </a:tr>
               <a:tr h="635000">
                 <a:tc>
@@ -10590,6 +10783,42 @@
                           <a:latin typeface="Pretendard"/>
                         </a:rPr>
                         <a:t>모델·추론 강도 변경</a:t>
+                      </a:r>
+                    </a:p>
+                  </a:txBody>
+                  <a:tcPr marL="101600" marR="101600" marT="101600" marB="101600" anchor="ctr">
+                    <a:solidFill>
+                      <a:srgbClr val="FFFFFF"/>
+                    </a:solidFill>
+                    <a:lnL w="0">
+                      <a:noFill/>
+                    </a:lnL>
+                    <a:lnR w="0">
+                      <a:noFill/>
+                    </a:lnR>
+                    <a:lnT w="0">
+                      <a:noFill/>
+                    </a:lnT>
+                    <a:lnB w="9525">
+                      <a:solidFill>
+                        <a:srgbClr val="E2E2E2"/>
+                      </a:solidFill>
+                    </a:lnB>
+                  </a:tcPr>
+                </a:tc>
+                <a:tc>
+                  <a:txBody>
+                    <a:bodyPr/>
+                    <a:lstStyle/>
+                    <a:p>
+                      <a:r>
+                        <a:rPr sz="1300" b="0">
+                          <a:solidFill>
+                            <a:srgbClr val="5E5E5E"/>
+                          </a:solidFill>
+                          <a:latin typeface="Pretendard Medium"/>
+                        </a:rPr>
+                        <a:t>/model</a:t>
                       </a:r>
                     </a:p>
                   </a:txBody>
@@ -10795,6 +11024,42 @@
                     </a:lnB>
                   </a:tcPr>
                 </a:tc>
+                <a:tc>
+                  <a:txBody>
+                    <a:bodyPr/>
+                    <a:lstStyle/>
+                    <a:p>
+                      <a:r>
+                        <a:rPr sz="1300" b="0">
+                          <a:solidFill>
+                            <a:srgbClr val="5E5E5E"/>
+                          </a:solidFill>
+                          <a:latin typeface="Pretendard Medium"/>
+                        </a:rPr>
+                        <a:t>/clear</a:t>
+                      </a:r>
+                    </a:p>
+                  </a:txBody>
+                  <a:tcPr marL="101600" marR="101600" marT="101600" marB="101600" anchor="ctr">
+                    <a:solidFill>
+                      <a:srgbClr val="FFFFFF"/>
+                    </a:solidFill>
+                    <a:lnL w="0">
+                      <a:noFill/>
+                    </a:lnL>
+                    <a:lnR w="0">
+                      <a:noFill/>
+                    </a:lnR>
+                    <a:lnT w="0">
+                      <a:noFill/>
+                    </a:lnT>
+                    <a:lnB w="9525">
+                      <a:solidFill>
+                        <a:srgbClr val="E2E2E2"/>
+                      </a:solidFill>
+                    </a:lnB>
+                  </a:tcPr>
+                </a:tc>
               </a:tr>
               <a:tr h="635000">
                 <a:tc>
@@ -10882,6 +11147,42 @@
                           <a:latin typeface="Pretendard Medium"/>
                         </a:rPr>
                         <a:t>/compact</a:t>
+                      </a:r>
+                    </a:p>
+                  </a:txBody>
+                  <a:tcPr marL="101600" marR="101600" marT="101600" marB="101600" anchor="ctr">
+                    <a:solidFill>
+                      <a:srgbClr val="FFFFFF"/>
+                    </a:solidFill>
+                    <a:lnL w="0">
+                      <a:noFill/>
+                    </a:lnL>
+                    <a:lnR w="0">
+                      <a:noFill/>
+                    </a:lnR>
+                    <a:lnT w="0">
+                      <a:noFill/>
+                    </a:lnT>
+                    <a:lnB w="9525">
+                      <a:solidFill>
+                        <a:srgbClr val="E2E2E2"/>
+                      </a:solidFill>
+                    </a:lnB>
+                  </a:tcPr>
+                </a:tc>
+                <a:tc>
+                  <a:txBody>
+                    <a:bodyPr/>
+                    <a:lstStyle/>
+                    <a:p>
+                      <a:r>
+                        <a:rPr sz="1300" b="0">
+                          <a:solidFill>
+                            <a:srgbClr val="5E5E5E"/>
+                          </a:solidFill>
+                          <a:latin typeface="Pretendard Medium"/>
+                        </a:rPr>
+                        <a:t>미지원</a:t>
                       </a:r>
                     </a:p>
                   </a:txBody>
@@ -11015,6 +11316,42 @@
                     </a:lnB>
                   </a:tcPr>
                 </a:tc>
+                <a:tc>
+                  <a:txBody>
+                    <a:bodyPr/>
+                    <a:lstStyle/>
+                    <a:p>
+                      <a:r>
+                        <a:rPr sz="1300" b="0">
+                          <a:solidFill>
+                            <a:srgbClr val="5E5E5E"/>
+                          </a:solidFill>
+                          <a:latin typeface="Pretendard Medium"/>
+                        </a:rPr>
+                        <a:t>미지원</a:t>
+                      </a:r>
+                    </a:p>
+                  </a:txBody>
+                  <a:tcPr marL="101600" marR="101600" marT="101600" marB="101600" anchor="ctr">
+                    <a:solidFill>
+                      <a:srgbClr val="FFFFFF"/>
+                    </a:solidFill>
+                    <a:lnL w="0">
+                      <a:noFill/>
+                    </a:lnL>
+                    <a:lnR w="0">
+                      <a:noFill/>
+                    </a:lnR>
+                    <a:lnT w="0">
+                      <a:noFill/>
+                    </a:lnT>
+                    <a:lnB w="9525">
+                      <a:solidFill>
+                        <a:srgbClr val="E2E2E2"/>
+                      </a:solidFill>
+                    </a:lnB>
+                  </a:tcPr>
+                </a:tc>
               </a:tr>
             </a:tbl>
           </a:graphicData>
@@ -11102,7 +11439,7 @@
           <a:lstStyle/>
           <a:p>
             <a:r>
-              <a:t>5.3 대화를 비우는 기준</a:t>
+              <a:t>5.2 대화를 비우는 기준</a:t>
             </a:r>
           </a:p>
         </p:txBody>
@@ -11123,7 +11460,7 @@
           <a:lstStyle/>
           <a:p>
             <a:r>
-              <a:t>5. 확인과 기록</a:t>
+              <a:t>5. 명령과 기록</a:t>
             </a:r>
           </a:p>
         </p:txBody>
@@ -11250,7 +11587,7 @@
           <a:lstStyle/>
           <a:p>
             <a:r>
-              <a:t>5.4 모델 선택</a:t>
+              <a:t>5.3 모델 선택</a:t>
             </a:r>
           </a:p>
         </p:txBody>
@@ -11271,7 +11608,7 @@
           <a:lstStyle/>
           <a:p>
             <a:r>
-              <a:t>5. 확인과 기록</a:t>
+              <a:t>5. 명령과 기록</a:t>
             </a:r>
           </a:p>
         </p:txBody>
@@ -11398,7 +11735,7 @@
           <a:lstStyle/>
           <a:p>
             <a:r>
-              <a:t>5.5 md 파일로 남기는 맥락</a:t>
+              <a:t>5.4 md 파일로 남기는 맥락</a:t>
             </a:r>
           </a:p>
         </p:txBody>
@@ -11419,7 +11756,7 @@
           <a:lstStyle/>
           <a:p>
             <a:r>
-              <a:t>5. 확인과 기록</a:t>
+              <a:t>5. 명령과 기록</a:t>
             </a:r>
           </a:p>
         </p:txBody>
@@ -12701,7 +13038,7 @@
                           </a:solidFill>
                           <a:latin typeface="Pretendard Medium"/>
                         </a:rPr>
-                        <a:t>앱 실행</a:t>
+                        <a:t>agy --version 또는 앱 실행</a:t>
                       </a:r>
                     </a:p>
                   </a:txBody>
@@ -12737,7 +13074,7 @@
                           </a:solidFill>
                           <a:latin typeface="Pretendard Medium"/>
                         </a:rPr>
-                        <a:t>구글 계정 로그인 상태</a:t>
+                        <a:t>버전 번호 또는 로그인 상태</a:t>
                       </a:r>
                     </a:p>
                   </a:txBody>
@@ -12897,6 +13234,12 @@
           <a:p>
             <a:pPr/>
             <a:r>
+              <a:t>실행: 프로젝트 폴더에서 claude · codex · agy</a:t>
+            </a:r>
+          </a:p>
+          <a:p>
+            <a:pPr/>
+            <a:r>
               <a:t>권한: 커밋으로 되돌릴 수 있는 폴더에서만 전면 자동 사용</a:t>
             </a:r>
           </a:p>
@@ -12904,12 +13247,6 @@
             <a:pPr/>
             <a:r>
               <a:t>관리: 작업 단위로 /clear · 결정과 절차는 md 파일에 기록</a:t>
-            </a:r>
-          </a:p>
-          <a:p>
-            <a:pPr/>
-            <a:r>
-              <a:t>확인: 행 수, 결측 처리, 필터 범위, 검증하지 않은 코드</a:t>
             </a:r>
           </a:p>
         </p:txBody>

</xml_diff>